<commit_message>
Embed 7 real matplotlib charts into presentation
Charts generated from cached repo data and embedded into slides:
- Slide 3:  RBA yield curve (linear vs cubic, discount factors)
- Slide 5:  Binomial tree convergence to Black-Scholes
- Slide 8:  Dollar-delta bar chart by strategy (CBA/BHP/CSL)
- Slide 9:  Portfolio P&L distribution with VaR/ES lines
- Slide 11: VaR & ES across correlation regimes (base/stressed/crisis)
- Slide 12: Scenario analysis P&L bar chart
- Slide 14: Portfolio wealth path & drawdown series

https://claude.ai/code/session_01PmnFJLy8K6D15mpoqjuHnD
</commit_message>
<xml_diff>
--- a/docs/A3_Presentation.pptx
+++ b/docs/A3_Presentation.pptx
@@ -4721,7 +4721,7 @@
         <p:spPr>
           <a:xfrm>
             <a:off x="228600" y="987552"/>
-            <a:ext cx="8686800" cy="411480"/>
+            <a:ext cx="8686800" cy="347472"/>
           </a:xfrm>
           <a:prstGeom prst="rect">
             <a:avLst/>
@@ -4734,7 +4734,7 @@
           <a:p>
             <a:pPr algn="l"/>
             <a:r>
-              <a:rPr sz="1000" b="0" i="0">
+              <a:rPr sz="950" b="0" i="0">
                 <a:solidFill>
                   <a:srgbClr val="2D3A6B"/>
                 </a:solidFill>
@@ -4753,8 +4753,8 @@
         </p:nvSpPr>
         <p:spPr>
           <a:xfrm>
-            <a:off x="228600" y="1444752"/>
-            <a:ext cx="3200400" cy="256032"/>
+            <a:off x="228600" y="1371600"/>
+            <a:ext cx="3200400" cy="228600"/>
           </a:xfrm>
           <a:prstGeom prst="rect">
             <a:avLst/>
@@ -4767,7 +4767,7 @@
           <a:p>
             <a:pPr algn="l"/>
             <a:r>
-              <a:rPr sz="1000" b="1" i="0">
+              <a:rPr sz="900" b="1" i="0">
                 <a:solidFill>
                   <a:srgbClr val="2D3A6B"/>
                 </a:solidFill>
@@ -4787,8 +4787,8 @@
           <p:nvPr/>
         </p:nvGraphicFramePr>
         <p:xfrm>
-          <a:off x="228600" y="1719072"/>
-          <a:ext cx="2926080" cy="822960"/>
+          <a:off x="228600" y="1618488"/>
+          <a:ext cx="2926080" cy="731520"/>
         </p:xfrm>
         <a:graphic>
           <a:graphicData uri="http://schemas.openxmlformats.org/drawingml/2006/table">
@@ -4802,7 +4802,7 @@
                 <a:gridCol w="731520"/>
                 <a:gridCol w="731520"/>
               </a:tblGrid>
-              <a:tr h="205740">
+              <a:tr h="182880">
                 <a:tc>
                   <a:txBody>
                     <a:bodyPr wrap="square"/>
@@ -4824,7 +4824,7 @@
                     <a:p>
                       <a:pPr algn="ctr"/>
                       <a:r>
-                        <a:rPr sz="900" b="1" i="0">
+                        <a:rPr sz="800" b="1" i="0">
                           <a:solidFill>
                             <a:srgbClr val="FFFFFF"/>
                           </a:solidFill>
@@ -4847,7 +4847,7 @@
                     <a:p>
                       <a:pPr algn="ctr"/>
                       <a:r>
-                        <a:rPr sz="900" b="1" i="0">
+                        <a:rPr sz="800" b="1" i="0">
                           <a:solidFill>
                             <a:srgbClr val="FFFFFF"/>
                           </a:solidFill>
@@ -4870,7 +4870,7 @@
                     <a:p>
                       <a:pPr algn="ctr"/>
                       <a:r>
-                        <a:rPr sz="900" b="1" i="0">
+                        <a:rPr sz="800" b="1" i="0">
                           <a:solidFill>
                             <a:srgbClr val="FFFFFF"/>
                           </a:solidFill>
@@ -4887,15 +4887,15 @@
                   </a:tcPr>
                 </a:tc>
               </a:tr>
-              <a:tr h="205740">
-                <a:tc>
-                  <a:txBody>
-                    <a:bodyPr wrap="square"/>
-                    <a:lstStyle/>
-                    <a:p>
-                      <a:pPr algn="ctr"/>
-                      <a:r>
-                        <a:rPr sz="900" b="1" i="0">
+              <a:tr h="182880">
+                <a:tc>
+                  <a:txBody>
+                    <a:bodyPr wrap="square"/>
+                    <a:lstStyle/>
+                    <a:p>
+                      <a:pPr algn="ctr"/>
+                      <a:r>
+                        <a:rPr sz="800" b="1" i="0">
                           <a:solidFill>
                             <a:srgbClr val="FFFFFF"/>
                           </a:solidFill>
@@ -4918,7 +4918,7 @@
                     <a:p>
                       <a:pPr algn="ctr"/>
                       <a:r>
-                        <a:rPr sz="900" b="0" i="0">
+                        <a:rPr sz="800" b="0" i="0">
                           <a:solidFill>
                             <a:srgbClr val="FFFFFF"/>
                           </a:solidFill>
@@ -4941,7 +4941,7 @@
                     <a:p>
                       <a:pPr algn="ctr"/>
                       <a:r>
-                        <a:rPr sz="900" b="0" i="0">
+                        <a:rPr sz="800" b="0" i="0">
                           <a:solidFill>
                             <a:srgbClr val="2D3A6B"/>
                           </a:solidFill>
@@ -4964,7 +4964,7 @@
                     <a:p>
                       <a:pPr algn="ctr"/>
                       <a:r>
-                        <a:rPr sz="900" b="0" i="0">
+                        <a:rPr sz="800" b="0" i="0">
                           <a:solidFill>
                             <a:srgbClr val="2D3A6B"/>
                           </a:solidFill>
@@ -4981,15 +4981,15 @@
                   </a:tcPr>
                 </a:tc>
               </a:tr>
-              <a:tr h="205740">
-                <a:tc>
-                  <a:txBody>
-                    <a:bodyPr wrap="square"/>
-                    <a:lstStyle/>
-                    <a:p>
-                      <a:pPr algn="ctr"/>
-                      <a:r>
-                        <a:rPr sz="900" b="1" i="0">
+              <a:tr h="182880">
+                <a:tc>
+                  <a:txBody>
+                    <a:bodyPr wrap="square"/>
+                    <a:lstStyle/>
+                    <a:p>
+                      <a:pPr algn="ctr"/>
+                      <a:r>
+                        <a:rPr sz="800" b="1" i="0">
                           <a:solidFill>
                             <a:srgbClr val="FFFFFF"/>
                           </a:solidFill>
@@ -5012,7 +5012,7 @@
                     <a:p>
                       <a:pPr algn="ctr"/>
                       <a:r>
-                        <a:rPr sz="900" b="0" i="0">
+                        <a:rPr sz="800" b="0" i="0">
                           <a:solidFill>
                             <a:srgbClr val="2D3A6B"/>
                           </a:solidFill>
@@ -5035,7 +5035,7 @@
                     <a:p>
                       <a:pPr algn="ctr"/>
                       <a:r>
-                        <a:rPr sz="900" b="0" i="0">
+                        <a:rPr sz="800" b="0" i="0">
                           <a:solidFill>
                             <a:srgbClr val="FFFFFF"/>
                           </a:solidFill>
@@ -5058,7 +5058,7 @@
                     <a:p>
                       <a:pPr algn="ctr"/>
                       <a:r>
-                        <a:rPr sz="900" b="0" i="0">
+                        <a:rPr sz="800" b="0" i="0">
                           <a:solidFill>
                             <a:srgbClr val="2D3A6B"/>
                           </a:solidFill>
@@ -5075,15 +5075,15 @@
                   </a:tcPr>
                 </a:tc>
               </a:tr>
-              <a:tr h="205740">
-                <a:tc>
-                  <a:txBody>
-                    <a:bodyPr wrap="square"/>
-                    <a:lstStyle/>
-                    <a:p>
-                      <a:pPr algn="ctr"/>
-                      <a:r>
-                        <a:rPr sz="900" b="1" i="0">
+              <a:tr h="182880">
+                <a:tc>
+                  <a:txBody>
+                    <a:bodyPr wrap="square"/>
+                    <a:lstStyle/>
+                    <a:p>
+                      <a:pPr algn="ctr"/>
+                      <a:r>
+                        <a:rPr sz="800" b="1" i="0">
                           <a:solidFill>
                             <a:srgbClr val="FFFFFF"/>
                           </a:solidFill>
@@ -5106,7 +5106,7 @@
                     <a:p>
                       <a:pPr algn="ctr"/>
                       <a:r>
-                        <a:rPr sz="900" b="0" i="0">
+                        <a:rPr sz="800" b="0" i="0">
                           <a:solidFill>
                             <a:srgbClr val="2D3A6B"/>
                           </a:solidFill>
@@ -5129,7 +5129,7 @@
                     <a:p>
                       <a:pPr algn="ctr"/>
                       <a:r>
-                        <a:rPr sz="900" b="0" i="0">
+                        <a:rPr sz="800" b="0" i="0">
                           <a:solidFill>
                             <a:srgbClr val="2D3A6B"/>
                           </a:solidFill>
@@ -5152,7 +5152,7 @@
                     <a:p>
                       <a:pPr algn="ctr"/>
                       <a:r>
-                        <a:rPr sz="900" b="0" i="0">
+                        <a:rPr sz="800" b="0" i="0">
                           <a:solidFill>
                             <a:srgbClr val="FFFFFF"/>
                           </a:solidFill>
@@ -5173,49 +5173,30 @@
           </a:graphicData>
         </a:graphic>
       </p:graphicFrame>
-      <p:sp>
-        <p:nvSpPr>
-          <p:cNvPr id="9" name="Rectangle 8"/>
-          <p:cNvSpPr/>
+      <p:pic>
+        <p:nvPicPr>
+          <p:cNvPr id="9" name="Picture 8" descr="chart5_correlation_stress.png"/>
+          <p:cNvPicPr>
+            <a:picLocks noChangeAspect="1"/>
+          </p:cNvPicPr>
           <p:nvPr/>
-        </p:nvSpPr>
-        <p:spPr>
-          <a:xfrm>
-            <a:off x="228600" y="2624328"/>
-            <a:ext cx="2743200" cy="365760"/>
+        </p:nvPicPr>
+        <p:blipFill>
+          <a:blip r:embed="rId2"/>
+          <a:stretch>
+            <a:fillRect/>
+          </a:stretch>
+        </p:blipFill>
+        <p:spPr>
+          <a:xfrm>
+            <a:off x="137160" y="2423160"/>
+            <a:ext cx="8869680" cy="2514600"/>
           </a:xfrm>
           <a:prstGeom prst="rect">
             <a:avLst/>
           </a:prstGeom>
-          <a:solidFill>
-            <a:srgbClr val="2D3A6B"/>
-          </a:solidFill>
-          <a:ln>
-            <a:noFill/>
-          </a:ln>
-        </p:spPr>
-        <p:style>
-          <a:lnRef idx="1">
-            <a:schemeClr val="accent1"/>
-          </a:lnRef>
-          <a:fillRef idx="3">
-            <a:schemeClr val="accent1"/>
-          </a:fillRef>
-          <a:effectRef idx="2">
-            <a:schemeClr val="accent1"/>
-          </a:effectRef>
-          <a:fontRef idx="minor">
-            <a:schemeClr val="lt1"/>
-          </a:fontRef>
-        </p:style>
-        <p:txBody>
-          <a:bodyPr rtlCol="0" anchor="ctr"/>
-          <a:lstStyle/>
-          <a:p>
-            <a:pPr algn="ctr"/>
-          </a:p>
-        </p:txBody>
-      </p:sp>
+        </p:spPr>
+      </p:pic>
       <p:sp>
         <p:nvSpPr>
           <p:cNvPr id="10" name="TextBox 9"/>
@@ -5224,8 +5205,8 @@
         </p:nvSpPr>
         <p:spPr>
           <a:xfrm>
-            <a:off x="274320" y="2651760"/>
-            <a:ext cx="2651760" cy="320040"/>
+            <a:off x="228600" y="4709160"/>
+            <a:ext cx="8686800" cy="256032"/>
           </a:xfrm>
           <a:prstGeom prst="rect">
             <a:avLst/>
@@ -5238,434 +5219,13 @@
           <a:p>
             <a:pPr algn="l"/>
             <a:r>
-              <a:rPr sz="1100" b="1" i="0">
-                <a:solidFill>
-                  <a:srgbClr val="FFFFFF"/>
-                </a:solidFill>
-                <a:latin typeface="Calibri"/>
-              </a:rPr>
-              <a:t>Base (empirical ρ≈0.3)</a:t>
-            </a:r>
-          </a:p>
-        </p:txBody>
-      </p:sp>
-      <p:sp>
-        <p:nvSpPr>
-          <p:cNvPr id="11" name="Rectangle 10"/>
-          <p:cNvSpPr/>
-          <p:nvPr/>
-        </p:nvSpPr>
-        <p:spPr>
-          <a:xfrm>
-            <a:off x="228600" y="2990088"/>
-            <a:ext cx="2743200" cy="1600200"/>
-          </a:xfrm>
-          <a:prstGeom prst="rect">
-            <a:avLst/>
-          </a:prstGeom>
-          <a:solidFill>
-            <a:srgbClr val="E8F0FF"/>
-          </a:solidFill>
-          <a:ln>
-            <a:noFill/>
-          </a:ln>
-        </p:spPr>
-        <p:style>
-          <a:lnRef idx="1">
-            <a:schemeClr val="accent1"/>
-          </a:lnRef>
-          <a:fillRef idx="3">
-            <a:schemeClr val="accent1"/>
-          </a:fillRef>
-          <a:effectRef idx="2">
-            <a:schemeClr val="accent1"/>
-          </a:effectRef>
-          <a:fontRef idx="minor">
-            <a:schemeClr val="lt1"/>
-          </a:fontRef>
-        </p:style>
-        <p:txBody>
-          <a:bodyPr rtlCol="0" anchor="ctr"/>
-          <a:lstStyle/>
-          <a:p>
-            <a:pPr algn="ctr"/>
-          </a:p>
-        </p:txBody>
-      </p:sp>
-      <p:sp>
-        <p:nvSpPr>
-          <p:cNvPr id="12" name="TextBox 11"/>
-          <p:cNvSpPr txBox="1"/>
-          <p:nvPr/>
-        </p:nvSpPr>
-        <p:spPr>
-          <a:xfrm>
-            <a:off x="274320" y="3026664"/>
-            <a:ext cx="2651760" cy="1508760"/>
-          </a:xfrm>
-          <a:prstGeom prst="rect">
-            <a:avLst/>
-          </a:prstGeom>
-          <a:noFill/>
-        </p:spPr>
-        <p:txBody>
-          <a:bodyPr wrap="square"/>
-          <a:lstStyle/>
-          <a:p>
-            <a:pPr algn="l"/>
-            <a:r>
-              <a:rPr sz="1000" b="0" i="0">
+              <a:rPr sz="900" b="1" i="0">
                 <a:solidFill>
                   <a:srgbClr val="2D3A6B"/>
                 </a:solidFill>
                 <a:latin typeface="Calibri"/>
               </a:rPr>
-              <a:t>VaR (95%, 10d): $12,775
-ES: $15,599
-Normal market conditions</a:t>
-            </a:r>
-          </a:p>
-        </p:txBody>
-      </p:sp>
-      <p:sp>
-        <p:nvSpPr>
-          <p:cNvPr id="13" name="Rectangle 12"/>
-          <p:cNvSpPr/>
-          <p:nvPr/>
-        </p:nvSpPr>
-        <p:spPr>
-          <a:xfrm>
-            <a:off x="3154680" y="2624328"/>
-            <a:ext cx="2743200" cy="365760"/>
-          </a:xfrm>
-          <a:prstGeom prst="rect">
-            <a:avLst/>
-          </a:prstGeom>
-          <a:solidFill>
-            <a:srgbClr val="5B8DEF"/>
-          </a:solidFill>
-          <a:ln>
-            <a:noFill/>
-          </a:ln>
-        </p:spPr>
-        <p:style>
-          <a:lnRef idx="1">
-            <a:schemeClr val="accent1"/>
-          </a:lnRef>
-          <a:fillRef idx="3">
-            <a:schemeClr val="accent1"/>
-          </a:fillRef>
-          <a:effectRef idx="2">
-            <a:schemeClr val="accent1"/>
-          </a:effectRef>
-          <a:fontRef idx="minor">
-            <a:schemeClr val="lt1"/>
-          </a:fontRef>
-        </p:style>
-        <p:txBody>
-          <a:bodyPr rtlCol="0" anchor="ctr"/>
-          <a:lstStyle/>
-          <a:p>
-            <a:pPr algn="ctr"/>
-          </a:p>
-        </p:txBody>
-      </p:sp>
-      <p:sp>
-        <p:nvSpPr>
-          <p:cNvPr id="14" name="TextBox 13"/>
-          <p:cNvSpPr txBox="1"/>
-          <p:nvPr/>
-        </p:nvSpPr>
-        <p:spPr>
-          <a:xfrm>
-            <a:off x="3200400" y="2651760"/>
-            <a:ext cx="2651760" cy="320040"/>
-          </a:xfrm>
-          <a:prstGeom prst="rect">
-            <a:avLst/>
-          </a:prstGeom>
-          <a:noFill/>
-        </p:spPr>
-        <p:txBody>
-          <a:bodyPr wrap="square"/>
-          <a:lstStyle/>
-          <a:p>
-            <a:pPr algn="l"/>
-            <a:r>
-              <a:rPr sz="1100" b="1" i="0">
-                <a:solidFill>
-                  <a:srgbClr val="FFFFFF"/>
-                </a:solidFill>
-                <a:latin typeface="Calibri"/>
-              </a:rPr>
-              <a:t>Stressed (ρ≈0.85)</a:t>
-            </a:r>
-          </a:p>
-        </p:txBody>
-      </p:sp>
-      <p:sp>
-        <p:nvSpPr>
-          <p:cNvPr id="15" name="Rectangle 14"/>
-          <p:cNvSpPr/>
-          <p:nvPr/>
-        </p:nvSpPr>
-        <p:spPr>
-          <a:xfrm>
-            <a:off x="3154680" y="2990088"/>
-            <a:ext cx="2743200" cy="1600200"/>
-          </a:xfrm>
-          <a:prstGeom prst="rect">
-            <a:avLst/>
-          </a:prstGeom>
-          <a:solidFill>
-            <a:srgbClr val="D6E6FF"/>
-          </a:solidFill>
-          <a:ln>
-            <a:noFill/>
-          </a:ln>
-        </p:spPr>
-        <p:style>
-          <a:lnRef idx="1">
-            <a:schemeClr val="accent1"/>
-          </a:lnRef>
-          <a:fillRef idx="3">
-            <a:schemeClr val="accent1"/>
-          </a:fillRef>
-          <a:effectRef idx="2">
-            <a:schemeClr val="accent1"/>
-          </a:effectRef>
-          <a:fontRef idx="minor">
-            <a:schemeClr val="lt1"/>
-          </a:fontRef>
-        </p:style>
-        <p:txBody>
-          <a:bodyPr rtlCol="0" anchor="ctr"/>
-          <a:lstStyle/>
-          <a:p>
-            <a:pPr algn="ctr"/>
-          </a:p>
-        </p:txBody>
-      </p:sp>
-      <p:sp>
-        <p:nvSpPr>
-          <p:cNvPr id="16" name="TextBox 15"/>
-          <p:cNvSpPr txBox="1"/>
-          <p:nvPr/>
-        </p:nvSpPr>
-        <p:spPr>
-          <a:xfrm>
-            <a:off x="3200400" y="3026664"/>
-            <a:ext cx="2651760" cy="1508760"/>
-          </a:xfrm>
-          <a:prstGeom prst="rect">
-            <a:avLst/>
-          </a:prstGeom>
-          <a:noFill/>
-        </p:spPr>
-        <p:txBody>
-          <a:bodyPr wrap="square"/>
-          <a:lstStyle/>
-          <a:p>
-            <a:pPr algn="l"/>
-            <a:r>
-              <a:rPr sz="1000" b="0" i="0">
-                <a:solidFill>
-                  <a:srgbClr val="2D3A6B"/>
-                </a:solidFill>
-                <a:latin typeface="Calibri"/>
-              </a:rPr>
-              <a:t>VaR (95%, 10d): $17,927
-ES: $21,787
-+40.3% VaR uplift vs base
-Comparable to 2008 GFC peaks</a:t>
-            </a:r>
-          </a:p>
-        </p:txBody>
-      </p:sp>
-      <p:sp>
-        <p:nvSpPr>
-          <p:cNvPr id="17" name="Rectangle 16"/>
-          <p:cNvSpPr/>
-          <p:nvPr/>
-        </p:nvSpPr>
-        <p:spPr>
-          <a:xfrm>
-            <a:off x="6080760" y="2624328"/>
-            <a:ext cx="2743200" cy="365760"/>
-          </a:xfrm>
-          <a:prstGeom prst="rect">
-            <a:avLst/>
-          </a:prstGeom>
-          <a:solidFill>
-            <a:srgbClr val="8B0000"/>
-          </a:solidFill>
-          <a:ln>
-            <a:noFill/>
-          </a:ln>
-        </p:spPr>
-        <p:style>
-          <a:lnRef idx="1">
-            <a:schemeClr val="accent1"/>
-          </a:lnRef>
-          <a:fillRef idx="3">
-            <a:schemeClr val="accent1"/>
-          </a:fillRef>
-          <a:effectRef idx="2">
-            <a:schemeClr val="accent1"/>
-          </a:effectRef>
-          <a:fontRef idx="minor">
-            <a:schemeClr val="lt1"/>
-          </a:fontRef>
-        </p:style>
-        <p:txBody>
-          <a:bodyPr rtlCol="0" anchor="ctr"/>
-          <a:lstStyle/>
-          <a:p>
-            <a:pPr algn="ctr"/>
-          </a:p>
-        </p:txBody>
-      </p:sp>
-      <p:sp>
-        <p:nvSpPr>
-          <p:cNvPr id="18" name="TextBox 17"/>
-          <p:cNvSpPr txBox="1"/>
-          <p:nvPr/>
-        </p:nvSpPr>
-        <p:spPr>
-          <a:xfrm>
-            <a:off x="6126480" y="2651760"/>
-            <a:ext cx="2651760" cy="320040"/>
-          </a:xfrm>
-          <a:prstGeom prst="rect">
-            <a:avLst/>
-          </a:prstGeom>
-          <a:noFill/>
-        </p:spPr>
-        <p:txBody>
-          <a:bodyPr wrap="square"/>
-          <a:lstStyle/>
-          <a:p>
-            <a:pPr algn="l"/>
-            <a:r>
-              <a:rPr sz="1100" b="1" i="0">
-                <a:solidFill>
-                  <a:srgbClr val="FFFFFF"/>
-                </a:solidFill>
-                <a:latin typeface="Calibri"/>
-              </a:rPr>
-              <a:t>Crisis (ρ≈0.99)</a:t>
-            </a:r>
-          </a:p>
-        </p:txBody>
-      </p:sp>
-      <p:sp>
-        <p:nvSpPr>
-          <p:cNvPr id="19" name="Rectangle 18"/>
-          <p:cNvSpPr/>
-          <p:nvPr/>
-        </p:nvSpPr>
-        <p:spPr>
-          <a:xfrm>
-            <a:off x="6080760" y="2990088"/>
-            <a:ext cx="2743200" cy="1600200"/>
-          </a:xfrm>
-          <a:prstGeom prst="rect">
-            <a:avLst/>
-          </a:prstGeom>
-          <a:solidFill>
-            <a:srgbClr val="FFE8E8"/>
-          </a:solidFill>
-          <a:ln>
-            <a:noFill/>
-          </a:ln>
-        </p:spPr>
-        <p:style>
-          <a:lnRef idx="1">
-            <a:schemeClr val="accent1"/>
-          </a:lnRef>
-          <a:fillRef idx="3">
-            <a:schemeClr val="accent1"/>
-          </a:fillRef>
-          <a:effectRef idx="2">
-            <a:schemeClr val="accent1"/>
-          </a:effectRef>
-          <a:fontRef idx="minor">
-            <a:schemeClr val="lt1"/>
-          </a:fontRef>
-        </p:style>
-        <p:txBody>
-          <a:bodyPr rtlCol="0" anchor="ctr"/>
-          <a:lstStyle/>
-          <a:p>
-            <a:pPr algn="ctr"/>
-          </a:p>
-        </p:txBody>
-      </p:sp>
-      <p:sp>
-        <p:nvSpPr>
-          <p:cNvPr id="20" name="TextBox 19"/>
-          <p:cNvSpPr txBox="1"/>
-          <p:nvPr/>
-        </p:nvSpPr>
-        <p:spPr>
-          <a:xfrm>
-            <a:off x="6126480" y="3026664"/>
-            <a:ext cx="2651760" cy="1508760"/>
-          </a:xfrm>
-          <a:prstGeom prst="rect">
-            <a:avLst/>
-          </a:prstGeom>
-          <a:noFill/>
-        </p:spPr>
-        <p:txBody>
-          <a:bodyPr wrap="square"/>
-          <a:lstStyle/>
-          <a:p>
-            <a:pPr algn="l"/>
-            <a:r>
-              <a:rPr sz="1000" b="0" i="0">
-                <a:solidFill>
-                  <a:srgbClr val="2D3A6B"/>
-                </a:solidFill>
-                <a:latin typeface="Calibri"/>
-              </a:rPr>
-              <a:t>VaR (95%, 10d): $18,379
-ES: $22,675
-+43.9% VaR uplift vs base
-Near perfect-correlation bound</a:t>
-            </a:r>
-          </a:p>
-        </p:txBody>
-      </p:sp>
-      <p:sp>
-        <p:nvSpPr>
-          <p:cNvPr id="21" name="TextBox 20"/>
-          <p:cNvSpPr txBox="1"/>
-          <p:nvPr/>
-        </p:nvSpPr>
-        <p:spPr>
-          <a:xfrm>
-            <a:off x="228600" y="4663440"/>
-            <a:ext cx="8686800" cy="274320"/>
-          </a:xfrm>
-          <a:prstGeom prst="rect">
-            <a:avLst/>
-          </a:prstGeom>
-          <a:noFill/>
-        </p:spPr>
-        <p:txBody>
-          <a:bodyPr wrap="square"/>
-          <a:lstStyle/>
-          <a:p>
-            <a:pPr algn="l"/>
-            <a:r>
-              <a:rPr sz="1000" b="1" i="0">
-                <a:solidFill>
-                  <a:srgbClr val="2D3A6B"/>
-                </a:solidFill>
-                <a:latin typeface="Calibri"/>
-              </a:rPr>
-              <a:t>⚠  Key observation: A risk dashboard ignoring correlation regimes systematically underestimates crisis-period losses.</a:t>
+              <a:t>Key observation: A risk dashboard ignoring correlation regimes systematically underestimates crisis-period losses.</a:t>
             </a:r>
           </a:p>
         </p:txBody>
@@ -5851,8 +5411,8 @@
           <p:nvPr/>
         </p:nvGraphicFramePr>
         <p:xfrm>
-          <a:off x="228600" y="1005840"/>
-          <a:ext cx="8686800" cy="2514600"/>
+          <a:off x="5806440" y="987552"/>
+          <a:ext cx="3200400" cy="2286000"/>
         </p:xfrm>
         <a:graphic>
           <a:graphicData uri="http://schemas.openxmlformats.org/drawingml/2006/table">
@@ -5861,21 +5421,19 @@
                 <a:tableStyleId>{5C22544A-7EE6-4342-B048-85BDC9FD1C3A}</a:tableStyleId>
               </a:tblPr>
               <a:tblGrid>
-                <a:gridCol w="2743200"/>
-                <a:gridCol w="1280160"/>
-                <a:gridCol w="1280160"/>
-                <a:gridCol w="1691640"/>
-                <a:gridCol w="1691640"/>
+                <a:gridCol w="1600200"/>
+                <a:gridCol w="868680"/>
+                <a:gridCol w="731520"/>
               </a:tblGrid>
-              <a:tr h="279400">
-                <a:tc>
-                  <a:txBody>
-                    <a:bodyPr wrap="square"/>
-                    <a:lstStyle/>
-                    <a:p>
-                      <a:pPr algn="ctr"/>
-                      <a:r>
-                        <a:rPr sz="1000" b="1" i="0">
+              <a:tr h="254000">
+                <a:tc>
+                  <a:txBody>
+                    <a:bodyPr wrap="square"/>
+                    <a:lstStyle/>
+                    <a:p>
+                      <a:pPr algn="ctr"/>
+                      <a:r>
+                        <a:rPr sz="800" b="1" i="0">
                           <a:solidFill>
                             <a:srgbClr val="FFFFFF"/>
                           </a:solidFill>
@@ -5898,13 +5456,13 @@
                     <a:p>
                       <a:pPr algn="ctr"/>
                       <a:r>
-                        <a:rPr sz="1000" b="1" i="0">
+                        <a:rPr sz="800" b="1" i="0">
                           <a:solidFill>
                             <a:srgbClr val="FFFFFF"/>
                           </a:solidFill>
                           <a:latin typeface="Calibri"/>
                         </a:rPr>
-                        <a:t>Spot Shock</a:t>
+                        <a:t>P&amp;L ($)</a:t>
                       </a:r>
                     </a:p>
                   </a:txBody>
@@ -5921,13 +5479,13 @@
                     <a:p>
                       <a:pPr algn="ctr"/>
                       <a:r>
-                        <a:rPr sz="1000" b="1" i="0">
+                        <a:rPr sz="800" b="1" i="0">
                           <a:solidFill>
                             <a:srgbClr val="FFFFFF"/>
                           </a:solidFill>
                           <a:latin typeface="Calibri"/>
                         </a:rPr>
-                        <a:t>Vol Shock</a:t>
+                        <a:t>P&amp;L (%)</a:t>
                       </a:r>
                     </a:p>
                   </a:txBody>
@@ -5937,20 +5495,22 @@
                     </a:solidFill>
                   </a:tcPr>
                 </a:tc>
-                <a:tc>
-                  <a:txBody>
-                    <a:bodyPr wrap="square"/>
-                    <a:lstStyle/>
-                    <a:p>
-                      <a:pPr algn="ctr"/>
-                      <a:r>
-                        <a:rPr sz="1000" b="1" i="0">
+              </a:tr>
+              <a:tr h="254000">
+                <a:tc>
+                  <a:txBody>
+                    <a:bodyPr wrap="square"/>
+                    <a:lstStyle/>
+                    <a:p>
+                      <a:pPr algn="l"/>
+                      <a:r>
+                        <a:rPr sz="800" b="1" i="0">
                           <a:solidFill>
                             <a:srgbClr val="FFFFFF"/>
                           </a:solidFill>
                           <a:latin typeface="Calibri"/>
                         </a:rPr>
-                        <a:t>P&amp;L ($)</a:t>
+                        <a:t>Base case</a:t>
                       </a:r>
                     </a:p>
                   </a:txBody>
@@ -5967,13 +5527,13 @@
                     <a:p>
                       <a:pPr algn="ctr"/>
                       <a:r>
-                        <a:rPr sz="1000" b="1" i="0">
+                        <a:rPr sz="800" b="1" i="0">
                           <a:solidFill>
                             <a:srgbClr val="FFFFFF"/>
                           </a:solidFill>
                           <a:latin typeface="Calibri"/>
                         </a:rPr>
-                        <a:t>P&amp;L (%)</a:t>
+                        <a:t>$0</a:t>
                       </a:r>
                     </a:p>
                   </a:txBody>
@@ -5983,8 +5543,31 @@
                     </a:solidFill>
                   </a:tcPr>
                 </a:tc>
+                <a:tc>
+                  <a:txBody>
+                    <a:bodyPr wrap="square"/>
+                    <a:lstStyle/>
+                    <a:p>
+                      <a:pPr algn="ctr"/>
+                      <a:r>
+                        <a:rPr sz="800" b="1" i="0">
+                          <a:solidFill>
+                            <a:srgbClr val="FFFFFF"/>
+                          </a:solidFill>
+                          <a:latin typeface="Calibri"/>
+                        </a:rPr>
+                        <a:t>0.00%</a:t>
+                      </a:r>
+                    </a:p>
+                  </a:txBody>
+                  <a:tcPr>
+                    <a:solidFill>
+                      <a:srgbClr val="2D3A6B"/>
+                    </a:solidFill>
+                  </a:tcPr>
+                </a:tc>
               </a:tr>
-              <a:tr h="279400">
+              <a:tr h="254000">
                 <a:tc>
                   <a:txBody>
                     <a:bodyPr wrap="square"/>
@@ -5992,116 +5575,70 @@
                     <a:p>
                       <a:pPr algn="l"/>
                       <a:r>
-                        <a:rPr sz="1000" b="1" i="0">
-                          <a:solidFill>
-                            <a:srgbClr val="FFFFFF"/>
-                          </a:solidFill>
-                          <a:latin typeface="Calibri"/>
-                        </a:rPr>
-                        <a:t>Base case</a:t>
-                      </a:r>
-                    </a:p>
-                  </a:txBody>
-                  <a:tcPr>
-                    <a:solidFill>
-                      <a:srgbClr val="2D3A6B"/>
-                    </a:solidFill>
-                  </a:tcPr>
-                </a:tc>
-                <a:tc>
-                  <a:txBody>
-                    <a:bodyPr wrap="square"/>
-                    <a:lstStyle/>
-                    <a:p>
-                      <a:pPr algn="ctr"/>
-                      <a:r>
-                        <a:rPr sz="1000" b="1" i="0">
-                          <a:solidFill>
-                            <a:srgbClr val="FFFFFF"/>
-                          </a:solidFill>
-                          <a:latin typeface="Calibri"/>
-                        </a:rPr>
-                        <a:t>+0%</a:t>
-                      </a:r>
-                    </a:p>
-                  </a:txBody>
-                  <a:tcPr>
-                    <a:solidFill>
-                      <a:srgbClr val="2D3A6B"/>
-                    </a:solidFill>
-                  </a:tcPr>
-                </a:tc>
-                <a:tc>
-                  <a:txBody>
-                    <a:bodyPr wrap="square"/>
-                    <a:lstStyle/>
-                    <a:p>
-                      <a:pPr algn="ctr"/>
-                      <a:r>
-                        <a:rPr sz="1000" b="1" i="0">
-                          <a:solidFill>
-                            <a:srgbClr val="FFFFFF"/>
-                          </a:solidFill>
-                          <a:latin typeface="Calibri"/>
-                        </a:rPr>
-                        <a:t>+0%</a:t>
-                      </a:r>
-                    </a:p>
-                  </a:txBody>
-                  <a:tcPr>
-                    <a:solidFill>
-                      <a:srgbClr val="2D3A6B"/>
-                    </a:solidFill>
-                  </a:tcPr>
-                </a:tc>
-                <a:tc>
-                  <a:txBody>
-                    <a:bodyPr wrap="square"/>
-                    <a:lstStyle/>
-                    <a:p>
-                      <a:pPr algn="ctr"/>
-                      <a:r>
-                        <a:rPr sz="1000" b="1" i="0">
-                          <a:solidFill>
-                            <a:srgbClr val="FFFFFF"/>
-                          </a:solidFill>
-                          <a:latin typeface="Calibri"/>
-                        </a:rPr>
-                        <a:t>$0</a:t>
-                      </a:r>
-                    </a:p>
-                  </a:txBody>
-                  <a:tcPr>
-                    <a:solidFill>
-                      <a:srgbClr val="2D3A6B"/>
-                    </a:solidFill>
-                  </a:tcPr>
-                </a:tc>
-                <a:tc>
-                  <a:txBody>
-                    <a:bodyPr wrap="square"/>
-                    <a:lstStyle/>
-                    <a:p>
-                      <a:pPr algn="ctr"/>
-                      <a:r>
-                        <a:rPr sz="1000" b="1" i="0">
-                          <a:solidFill>
-                            <a:srgbClr val="FFFFFF"/>
-                          </a:solidFill>
-                          <a:latin typeface="Calibri"/>
-                        </a:rPr>
-                        <a:t>0.00%</a:t>
-                      </a:r>
-                    </a:p>
-                  </a:txBody>
-                  <a:tcPr>
-                    <a:solidFill>
-                      <a:srgbClr val="2D3A6B"/>
+                        <a:rPr sz="800" b="0" i="0">
+                          <a:solidFill>
+                            <a:srgbClr val="2D3A6B"/>
+                          </a:solidFill>
+                          <a:latin typeface="Calibri"/>
+                        </a:rPr>
+                        <a:t>Equity −10%</a:t>
+                      </a:r>
+                    </a:p>
+                  </a:txBody>
+                  <a:tcPr>
+                    <a:solidFill>
+                      <a:srgbClr val="F0F4FF"/>
+                    </a:solidFill>
+                  </a:tcPr>
+                </a:tc>
+                <a:tc>
+                  <a:txBody>
+                    <a:bodyPr wrap="square"/>
+                    <a:lstStyle/>
+                    <a:p>
+                      <a:pPr algn="ctr"/>
+                      <a:r>
+                        <a:rPr sz="800" b="0" i="0">
+                          <a:solidFill>
+                            <a:srgbClr val="2D3A6B"/>
+                          </a:solidFill>
+                          <a:latin typeface="Calibri"/>
+                        </a:rPr>
+                        <a:t>−$21,782</a:t>
+                      </a:r>
+                    </a:p>
+                  </a:txBody>
+                  <a:tcPr>
+                    <a:solidFill>
+                      <a:srgbClr val="F0F4FF"/>
+                    </a:solidFill>
+                  </a:tcPr>
+                </a:tc>
+                <a:tc>
+                  <a:txBody>
+                    <a:bodyPr wrap="square"/>
+                    <a:lstStyle/>
+                    <a:p>
+                      <a:pPr algn="ctr"/>
+                      <a:r>
+                        <a:rPr sz="800" b="0" i="0">
+                          <a:solidFill>
+                            <a:srgbClr val="2D3A6B"/>
+                          </a:solidFill>
+                          <a:latin typeface="Calibri"/>
+                        </a:rPr>
+                        <a:t>−7.11%</a:t>
+                      </a:r>
+                    </a:p>
+                  </a:txBody>
+                  <a:tcPr>
+                    <a:solidFill>
+                      <a:srgbClr val="F0F4FF"/>
                     </a:solidFill>
                   </a:tcPr>
                 </a:tc>
               </a:tr>
-              <a:tr h="279400">
+              <a:tr h="254000">
                 <a:tc>
                   <a:txBody>
                     <a:bodyPr wrap="square"/>
@@ -6109,13 +5646,84 @@
                     <a:p>
                       <a:pPr algn="l"/>
                       <a:r>
-                        <a:rPr sz="1000" b="0" i="0">
-                          <a:solidFill>
-                            <a:srgbClr val="2D3A6B"/>
-                          </a:solidFill>
-                          <a:latin typeface="Calibri"/>
-                        </a:rPr>
-                        <a:t>Equity −10%</a:t>
+                        <a:rPr sz="800" b="0" i="0">
+                          <a:solidFill>
+                            <a:srgbClr val="2D3A6B"/>
+                          </a:solidFill>
+                          <a:latin typeface="Calibri"/>
+                        </a:rPr>
+                        <a:t>Equity −20%</a:t>
+                      </a:r>
+                    </a:p>
+                  </a:txBody>
+                  <a:tcPr>
+                    <a:solidFill>
+                      <a:srgbClr val="FFFFFF"/>
+                    </a:solidFill>
+                  </a:tcPr>
+                </a:tc>
+                <a:tc>
+                  <a:txBody>
+                    <a:bodyPr wrap="square"/>
+                    <a:lstStyle/>
+                    <a:p>
+                      <a:pPr algn="ctr"/>
+                      <a:r>
+                        <a:rPr sz="800" b="0" i="0">
+                          <a:solidFill>
+                            <a:srgbClr val="2D3A6B"/>
+                          </a:solidFill>
+                          <a:latin typeface="Calibri"/>
+                        </a:rPr>
+                        <a:t>−$41,180</a:t>
+                      </a:r>
+                    </a:p>
+                  </a:txBody>
+                  <a:tcPr>
+                    <a:solidFill>
+                      <a:srgbClr val="FFFFFF"/>
+                    </a:solidFill>
+                  </a:tcPr>
+                </a:tc>
+                <a:tc>
+                  <a:txBody>
+                    <a:bodyPr wrap="square"/>
+                    <a:lstStyle/>
+                    <a:p>
+                      <a:pPr algn="ctr"/>
+                      <a:r>
+                        <a:rPr sz="800" b="0" i="0">
+                          <a:solidFill>
+                            <a:srgbClr val="2D3A6B"/>
+                          </a:solidFill>
+                          <a:latin typeface="Calibri"/>
+                        </a:rPr>
+                        <a:t>−13.43%</a:t>
+                      </a:r>
+                    </a:p>
+                  </a:txBody>
+                  <a:tcPr>
+                    <a:solidFill>
+                      <a:srgbClr val="FFFFFF"/>
+                    </a:solidFill>
+                  </a:tcPr>
+                </a:tc>
+              </a:tr>
+              <a:tr h="254000">
+                <a:tc>
+                  <a:txBody>
+                    <a:bodyPr wrap="square"/>
+                    <a:lstStyle/>
+                    <a:p>
+                      <a:pPr algn="l"/>
+                      <a:r>
+                        <a:rPr sz="800" b="0" i="0">
+                          <a:solidFill>
+                            <a:srgbClr val="2D3A6B"/>
+                          </a:solidFill>
+                          <a:latin typeface="Calibri"/>
+                        </a:rPr>
+                        <a:t>Equity +10%</a:t>
                       </a:r>
                     </a:p>
                   </a:txBody>
@@ -6132,13 +5740,13 @@
                     <a:p>
                       <a:pPr algn="ctr"/>
                       <a:r>
-                        <a:rPr sz="1000" b="0" i="0">
-                          <a:solidFill>
-                            <a:srgbClr val="2D3A6B"/>
-                          </a:solidFill>
-                          <a:latin typeface="Calibri"/>
-                        </a:rPr>
-                        <a:t>−10%</a:t>
+                        <a:rPr sz="800" b="0" i="0">
+                          <a:solidFill>
+                            <a:srgbClr val="2D3A6B"/>
+                          </a:solidFill>
+                          <a:latin typeface="Calibri"/>
+                        </a:rPr>
+                        <a:t>+$23,402</a:t>
                       </a:r>
                     </a:p>
                   </a:txBody>
@@ -6155,13 +5763,13 @@
                     <a:p>
                       <a:pPr algn="ctr"/>
                       <a:r>
-                        <a:rPr sz="1000" b="0" i="0">
-                          <a:solidFill>
-                            <a:srgbClr val="2D3A6B"/>
-                          </a:solidFill>
-                          <a:latin typeface="Calibri"/>
-                        </a:rPr>
-                        <a:t>+0%</a:t>
+                        <a:rPr sz="800" b="0" i="0">
+                          <a:solidFill>
+                            <a:srgbClr val="2D3A6B"/>
+                          </a:solidFill>
+                          <a:latin typeface="Calibri"/>
+                        </a:rPr>
+                        <a:t>+7.64%</a:t>
                       </a:r>
                     </a:p>
                   </a:txBody>
@@ -6171,20 +5779,93 @@
                     </a:solidFill>
                   </a:tcPr>
                 </a:tc>
-                <a:tc>
-                  <a:txBody>
-                    <a:bodyPr wrap="square"/>
-                    <a:lstStyle/>
-                    <a:p>
-                      <a:pPr algn="ctr"/>
-                      <a:r>
-                        <a:rPr sz="1000" b="0" i="0">
-                          <a:solidFill>
-                            <a:srgbClr val="2D3A6B"/>
-                          </a:solidFill>
-                          <a:latin typeface="Calibri"/>
-                        </a:rPr>
-                        <a:t>−$21,782</a:t>
+              </a:tr>
+              <a:tr h="254000">
+                <a:tc>
+                  <a:txBody>
+                    <a:bodyPr wrap="square"/>
+                    <a:lstStyle/>
+                    <a:p>
+                      <a:pPr algn="l"/>
+                      <a:r>
+                        <a:rPr sz="800" b="0" i="0">
+                          <a:solidFill>
+                            <a:srgbClr val="2D3A6B"/>
+                          </a:solidFill>
+                          <a:latin typeface="Calibri"/>
+                        </a:rPr>
+                        <a:t>Equity +20%</a:t>
+                      </a:r>
+                    </a:p>
+                  </a:txBody>
+                  <a:tcPr>
+                    <a:solidFill>
+                      <a:srgbClr val="FFFFFF"/>
+                    </a:solidFill>
+                  </a:tcPr>
+                </a:tc>
+                <a:tc>
+                  <a:txBody>
+                    <a:bodyPr wrap="square"/>
+                    <a:lstStyle/>
+                    <a:p>
+                      <a:pPr algn="ctr"/>
+                      <a:r>
+                        <a:rPr sz="800" b="0" i="0">
+                          <a:solidFill>
+                            <a:srgbClr val="2D3A6B"/>
+                          </a:solidFill>
+                          <a:latin typeface="Calibri"/>
+                        </a:rPr>
+                        <a:t>+$47,565</a:t>
+                      </a:r>
+                    </a:p>
+                  </a:txBody>
+                  <a:tcPr>
+                    <a:solidFill>
+                      <a:srgbClr val="FFFFFF"/>
+                    </a:solidFill>
+                  </a:tcPr>
+                </a:tc>
+                <a:tc>
+                  <a:txBody>
+                    <a:bodyPr wrap="square"/>
+                    <a:lstStyle/>
+                    <a:p>
+                      <a:pPr algn="ctr"/>
+                      <a:r>
+                        <a:rPr sz="800" b="0" i="0">
+                          <a:solidFill>
+                            <a:srgbClr val="2D3A6B"/>
+                          </a:solidFill>
+                          <a:latin typeface="Calibri"/>
+                        </a:rPr>
+                        <a:t>+15.52%</a:t>
+                      </a:r>
+                    </a:p>
+                  </a:txBody>
+                  <a:tcPr>
+                    <a:solidFill>
+                      <a:srgbClr val="FFFFFF"/>
+                    </a:solidFill>
+                  </a:tcPr>
+                </a:tc>
+              </a:tr>
+              <a:tr h="254000">
+                <a:tc>
+                  <a:txBody>
+                    <a:bodyPr wrap="square"/>
+                    <a:lstStyle/>
+                    <a:p>
+                      <a:pPr algn="l"/>
+                      <a:r>
+                        <a:rPr sz="800" b="0" i="0">
+                          <a:solidFill>
+                            <a:srgbClr val="2D3A6B"/>
+                          </a:solidFill>
+                          <a:latin typeface="Calibri"/>
+                        </a:rPr>
+                        <a:t>Vol shock +30%</a:t>
                       </a:r>
                     </a:p>
                   </a:txBody>
@@ -6201,13 +5882,13 @@
                     <a:p>
                       <a:pPr algn="ctr"/>
                       <a:r>
-                        <a:rPr sz="1000" b="0" i="0">
-                          <a:solidFill>
-                            <a:srgbClr val="2D3A6B"/>
-                          </a:solidFill>
-                          <a:latin typeface="Calibri"/>
-                        </a:rPr>
-                        <a:t>−7.11%</a:t>
+                        <a:rPr sz="800" b="0" i="0">
+                          <a:solidFill>
+                            <a:srgbClr val="2D3A6B"/>
+                          </a:solidFill>
+                          <a:latin typeface="Calibri"/>
+                        </a:rPr>
+                        <a:t>+$2,150</a:t>
                       </a:r>
                     </a:p>
                   </a:txBody>
@@ -6217,8 +5898,31 @@
                     </a:solidFill>
                   </a:tcPr>
                 </a:tc>
+                <a:tc>
+                  <a:txBody>
+                    <a:bodyPr wrap="square"/>
+                    <a:lstStyle/>
+                    <a:p>
+                      <a:pPr algn="ctr"/>
+                      <a:r>
+                        <a:rPr sz="800" b="0" i="0">
+                          <a:solidFill>
+                            <a:srgbClr val="2D3A6B"/>
+                          </a:solidFill>
+                          <a:latin typeface="Calibri"/>
+                        </a:rPr>
+                        <a:t>+0.70%</a:t>
+                      </a:r>
+                    </a:p>
+                  </a:txBody>
+                  <a:tcPr>
+                    <a:solidFill>
+                      <a:srgbClr val="F0F4FF"/>
+                    </a:solidFill>
+                  </a:tcPr>
+                </a:tc>
               </a:tr>
-              <a:tr h="279400">
+              <a:tr h="254000">
                 <a:tc>
                   <a:txBody>
                     <a:bodyPr wrap="square"/>
@@ -6226,13 +5930,13 @@
                     <a:p>
                       <a:pPr algn="l"/>
                       <a:r>
-                        <a:rPr sz="1000" b="0" i="0">
-                          <a:solidFill>
-                            <a:srgbClr val="2D3A6B"/>
-                          </a:solidFill>
-                          <a:latin typeface="Calibri"/>
-                        </a:rPr>
-                        <a:t>Equity −20%</a:t>
+                        <a:rPr sz="800" b="0" i="0">
+                          <a:solidFill>
+                            <a:srgbClr val="2D3A6B"/>
+                          </a:solidFill>
+                          <a:latin typeface="Calibri"/>
+                        </a:rPr>
+                        <a:t>Vol shock +50%</a:t>
                       </a:r>
                     </a:p>
                   </a:txBody>
@@ -6249,13 +5953,13 @@
                     <a:p>
                       <a:pPr algn="ctr"/>
                       <a:r>
-                        <a:rPr sz="1000" b="0" i="0">
-                          <a:solidFill>
-                            <a:srgbClr val="2D3A6B"/>
-                          </a:solidFill>
-                          <a:latin typeface="Calibri"/>
-                        </a:rPr>
-                        <a:t>−20%</a:t>
+                        <a:rPr sz="800" b="0" i="0">
+                          <a:solidFill>
+                            <a:srgbClr val="2D3A6B"/>
+                          </a:solidFill>
+                          <a:latin typeface="Calibri"/>
+                        </a:rPr>
+                        <a:t>+$3,587</a:t>
                       </a:r>
                     </a:p>
                   </a:txBody>
@@ -6272,13 +5976,13 @@
                     <a:p>
                       <a:pPr algn="ctr"/>
                       <a:r>
-                        <a:rPr sz="1000" b="0" i="0">
-                          <a:solidFill>
-                            <a:srgbClr val="2D3A6B"/>
-                          </a:solidFill>
-                          <a:latin typeface="Calibri"/>
-                        </a:rPr>
-                        <a:t>+0%</a:t>
+                        <a:rPr sz="800" b="0" i="0">
+                          <a:solidFill>
+                            <a:srgbClr val="2D3A6B"/>
+                          </a:solidFill>
+                          <a:latin typeface="Calibri"/>
+                        </a:rPr>
+                        <a:t>+1.17%</a:t>
                       </a:r>
                     </a:p>
                   </a:txBody>
@@ -6288,54 +5992,8 @@
                     </a:solidFill>
                   </a:tcPr>
                 </a:tc>
-                <a:tc>
-                  <a:txBody>
-                    <a:bodyPr wrap="square"/>
-                    <a:lstStyle/>
-                    <a:p>
-                      <a:pPr algn="ctr"/>
-                      <a:r>
-                        <a:rPr sz="1000" b="0" i="0">
-                          <a:solidFill>
-                            <a:srgbClr val="2D3A6B"/>
-                          </a:solidFill>
-                          <a:latin typeface="Calibri"/>
-                        </a:rPr>
-                        <a:t>−$41,180</a:t>
-                      </a:r>
-                    </a:p>
-                  </a:txBody>
-                  <a:tcPr>
-                    <a:solidFill>
-                      <a:srgbClr val="FFFFFF"/>
-                    </a:solidFill>
-                  </a:tcPr>
-                </a:tc>
-                <a:tc>
-                  <a:txBody>
-                    <a:bodyPr wrap="square"/>
-                    <a:lstStyle/>
-                    <a:p>
-                      <a:pPr algn="ctr"/>
-                      <a:r>
-                        <a:rPr sz="1000" b="0" i="0">
-                          <a:solidFill>
-                            <a:srgbClr val="2D3A6B"/>
-                          </a:solidFill>
-                          <a:latin typeface="Calibri"/>
-                        </a:rPr>
-                        <a:t>−13.43%</a:t>
-                      </a:r>
-                    </a:p>
-                  </a:txBody>
-                  <a:tcPr>
-                    <a:solidFill>
-                      <a:srgbClr val="FFFFFF"/>
-                    </a:solidFill>
-                  </a:tcPr>
-                </a:tc>
               </a:tr>
-              <a:tr h="279400">
+              <a:tr h="254000">
                 <a:tc>
                   <a:txBody>
                     <a:bodyPr wrap="square"/>
@@ -6343,481 +6001,13 @@
                     <a:p>
                       <a:pPr algn="l"/>
                       <a:r>
-                        <a:rPr sz="1000" b="0" i="0">
-                          <a:solidFill>
-                            <a:srgbClr val="2D3A6B"/>
-                          </a:solidFill>
-                          <a:latin typeface="Calibri"/>
-                        </a:rPr>
-                        <a:t>Equity +10%</a:t>
-                      </a:r>
-                    </a:p>
-                  </a:txBody>
-                  <a:tcPr>
-                    <a:solidFill>
-                      <a:srgbClr val="F0F4FF"/>
-                    </a:solidFill>
-                  </a:tcPr>
-                </a:tc>
-                <a:tc>
-                  <a:txBody>
-                    <a:bodyPr wrap="square"/>
-                    <a:lstStyle/>
-                    <a:p>
-                      <a:pPr algn="ctr"/>
-                      <a:r>
-                        <a:rPr sz="1000" b="0" i="0">
-                          <a:solidFill>
-                            <a:srgbClr val="2D3A6B"/>
-                          </a:solidFill>
-                          <a:latin typeface="Calibri"/>
-                        </a:rPr>
-                        <a:t>+10%</a:t>
-                      </a:r>
-                    </a:p>
-                  </a:txBody>
-                  <a:tcPr>
-                    <a:solidFill>
-                      <a:srgbClr val="F0F4FF"/>
-                    </a:solidFill>
-                  </a:tcPr>
-                </a:tc>
-                <a:tc>
-                  <a:txBody>
-                    <a:bodyPr wrap="square"/>
-                    <a:lstStyle/>
-                    <a:p>
-                      <a:pPr algn="ctr"/>
-                      <a:r>
-                        <a:rPr sz="1000" b="0" i="0">
-                          <a:solidFill>
-                            <a:srgbClr val="2D3A6B"/>
-                          </a:solidFill>
-                          <a:latin typeface="Calibri"/>
-                        </a:rPr>
-                        <a:t>+0%</a:t>
-                      </a:r>
-                    </a:p>
-                  </a:txBody>
-                  <a:tcPr>
-                    <a:solidFill>
-                      <a:srgbClr val="F0F4FF"/>
-                    </a:solidFill>
-                  </a:tcPr>
-                </a:tc>
-                <a:tc>
-                  <a:txBody>
-                    <a:bodyPr wrap="square"/>
-                    <a:lstStyle/>
-                    <a:p>
-                      <a:pPr algn="ctr"/>
-                      <a:r>
-                        <a:rPr sz="1000" b="0" i="0">
-                          <a:solidFill>
-                            <a:srgbClr val="2D3A6B"/>
-                          </a:solidFill>
-                          <a:latin typeface="Calibri"/>
-                        </a:rPr>
-                        <a:t>+$23,402</a:t>
-                      </a:r>
-                    </a:p>
-                  </a:txBody>
-                  <a:tcPr>
-                    <a:solidFill>
-                      <a:srgbClr val="F0F4FF"/>
-                    </a:solidFill>
-                  </a:tcPr>
-                </a:tc>
-                <a:tc>
-                  <a:txBody>
-                    <a:bodyPr wrap="square"/>
-                    <a:lstStyle/>
-                    <a:p>
-                      <a:pPr algn="ctr"/>
-                      <a:r>
-                        <a:rPr sz="1000" b="0" i="0">
-                          <a:solidFill>
-                            <a:srgbClr val="2D3A6B"/>
-                          </a:solidFill>
-                          <a:latin typeface="Calibri"/>
-                        </a:rPr>
-                        <a:t>+7.64%</a:t>
-                      </a:r>
-                    </a:p>
-                  </a:txBody>
-                  <a:tcPr>
-                    <a:solidFill>
-                      <a:srgbClr val="F0F4FF"/>
-                    </a:solidFill>
-                  </a:tcPr>
-                </a:tc>
-              </a:tr>
-              <a:tr h="279400">
-                <a:tc>
-                  <a:txBody>
-                    <a:bodyPr wrap="square"/>
-                    <a:lstStyle/>
-                    <a:p>
-                      <a:pPr algn="l"/>
-                      <a:r>
-                        <a:rPr sz="1000" b="0" i="0">
-                          <a:solidFill>
-                            <a:srgbClr val="2D3A6B"/>
-                          </a:solidFill>
-                          <a:latin typeface="Calibri"/>
-                        </a:rPr>
-                        <a:t>Equity +20%</a:t>
-                      </a:r>
-                    </a:p>
-                  </a:txBody>
-                  <a:tcPr>
-                    <a:solidFill>
-                      <a:srgbClr val="FFFFFF"/>
-                    </a:solidFill>
-                  </a:tcPr>
-                </a:tc>
-                <a:tc>
-                  <a:txBody>
-                    <a:bodyPr wrap="square"/>
-                    <a:lstStyle/>
-                    <a:p>
-                      <a:pPr algn="ctr"/>
-                      <a:r>
-                        <a:rPr sz="1000" b="0" i="0">
-                          <a:solidFill>
-                            <a:srgbClr val="2D3A6B"/>
-                          </a:solidFill>
-                          <a:latin typeface="Calibri"/>
-                        </a:rPr>
-                        <a:t>+20%</a:t>
-                      </a:r>
-                    </a:p>
-                  </a:txBody>
-                  <a:tcPr>
-                    <a:solidFill>
-                      <a:srgbClr val="FFFFFF"/>
-                    </a:solidFill>
-                  </a:tcPr>
-                </a:tc>
-                <a:tc>
-                  <a:txBody>
-                    <a:bodyPr wrap="square"/>
-                    <a:lstStyle/>
-                    <a:p>
-                      <a:pPr algn="ctr"/>
-                      <a:r>
-                        <a:rPr sz="1000" b="0" i="0">
-                          <a:solidFill>
-                            <a:srgbClr val="2D3A6B"/>
-                          </a:solidFill>
-                          <a:latin typeface="Calibri"/>
-                        </a:rPr>
-                        <a:t>+0%</a:t>
-                      </a:r>
-                    </a:p>
-                  </a:txBody>
-                  <a:tcPr>
-                    <a:solidFill>
-                      <a:srgbClr val="FFFFFF"/>
-                    </a:solidFill>
-                  </a:tcPr>
-                </a:tc>
-                <a:tc>
-                  <a:txBody>
-                    <a:bodyPr wrap="square"/>
-                    <a:lstStyle/>
-                    <a:p>
-                      <a:pPr algn="ctr"/>
-                      <a:r>
-                        <a:rPr sz="1000" b="0" i="0">
-                          <a:solidFill>
-                            <a:srgbClr val="2D3A6B"/>
-                          </a:solidFill>
-                          <a:latin typeface="Calibri"/>
-                        </a:rPr>
-                        <a:t>+$47,565</a:t>
-                      </a:r>
-                    </a:p>
-                  </a:txBody>
-                  <a:tcPr>
-                    <a:solidFill>
-                      <a:srgbClr val="FFFFFF"/>
-                    </a:solidFill>
-                  </a:tcPr>
-                </a:tc>
-                <a:tc>
-                  <a:txBody>
-                    <a:bodyPr wrap="square"/>
-                    <a:lstStyle/>
-                    <a:p>
-                      <a:pPr algn="ctr"/>
-                      <a:r>
-                        <a:rPr sz="1000" b="0" i="0">
-                          <a:solidFill>
-                            <a:srgbClr val="2D3A6B"/>
-                          </a:solidFill>
-                          <a:latin typeface="Calibri"/>
-                        </a:rPr>
-                        <a:t>+15.52%</a:t>
-                      </a:r>
-                    </a:p>
-                  </a:txBody>
-                  <a:tcPr>
-                    <a:solidFill>
-                      <a:srgbClr val="FFFFFF"/>
-                    </a:solidFill>
-                  </a:tcPr>
-                </a:tc>
-              </a:tr>
-              <a:tr h="279400">
-                <a:tc>
-                  <a:txBody>
-                    <a:bodyPr wrap="square"/>
-                    <a:lstStyle/>
-                    <a:p>
-                      <a:pPr algn="l"/>
-                      <a:r>
-                        <a:rPr sz="1000" b="0" i="0">
-                          <a:solidFill>
-                            <a:srgbClr val="2D3A6B"/>
-                          </a:solidFill>
-                          <a:latin typeface="Calibri"/>
-                        </a:rPr>
-                        <a:t>Vol shock +30%</a:t>
-                      </a:r>
-                    </a:p>
-                  </a:txBody>
-                  <a:tcPr>
-                    <a:solidFill>
-                      <a:srgbClr val="F0F4FF"/>
-                    </a:solidFill>
-                  </a:tcPr>
-                </a:tc>
-                <a:tc>
-                  <a:txBody>
-                    <a:bodyPr wrap="square"/>
-                    <a:lstStyle/>
-                    <a:p>
-                      <a:pPr algn="ctr"/>
-                      <a:r>
-                        <a:rPr sz="1000" b="0" i="0">
-                          <a:solidFill>
-                            <a:srgbClr val="2D3A6B"/>
-                          </a:solidFill>
-                          <a:latin typeface="Calibri"/>
-                        </a:rPr>
-                        <a:t>+0%</a:t>
-                      </a:r>
-                    </a:p>
-                  </a:txBody>
-                  <a:tcPr>
-                    <a:solidFill>
-                      <a:srgbClr val="F0F4FF"/>
-                    </a:solidFill>
-                  </a:tcPr>
-                </a:tc>
-                <a:tc>
-                  <a:txBody>
-                    <a:bodyPr wrap="square"/>
-                    <a:lstStyle/>
-                    <a:p>
-                      <a:pPr algn="ctr"/>
-                      <a:r>
-                        <a:rPr sz="1000" b="0" i="0">
-                          <a:solidFill>
-                            <a:srgbClr val="2D3A6B"/>
-                          </a:solidFill>
-                          <a:latin typeface="Calibri"/>
-                        </a:rPr>
-                        <a:t>+30%</a:t>
-                      </a:r>
-                    </a:p>
-                  </a:txBody>
-                  <a:tcPr>
-                    <a:solidFill>
-                      <a:srgbClr val="F0F4FF"/>
-                    </a:solidFill>
-                  </a:tcPr>
-                </a:tc>
-                <a:tc>
-                  <a:txBody>
-                    <a:bodyPr wrap="square"/>
-                    <a:lstStyle/>
-                    <a:p>
-                      <a:pPr algn="ctr"/>
-                      <a:r>
-                        <a:rPr sz="1000" b="0" i="0">
-                          <a:solidFill>
-                            <a:srgbClr val="2D3A6B"/>
-                          </a:solidFill>
-                          <a:latin typeface="Calibri"/>
-                        </a:rPr>
-                        <a:t>+$2,150</a:t>
-                      </a:r>
-                    </a:p>
-                  </a:txBody>
-                  <a:tcPr>
-                    <a:solidFill>
-                      <a:srgbClr val="F0F4FF"/>
-                    </a:solidFill>
-                  </a:tcPr>
-                </a:tc>
-                <a:tc>
-                  <a:txBody>
-                    <a:bodyPr wrap="square"/>
-                    <a:lstStyle/>
-                    <a:p>
-                      <a:pPr algn="ctr"/>
-                      <a:r>
-                        <a:rPr sz="1000" b="0" i="0">
-                          <a:solidFill>
-                            <a:srgbClr val="2D3A6B"/>
-                          </a:solidFill>
-                          <a:latin typeface="Calibri"/>
-                        </a:rPr>
-                        <a:t>+0.70%</a:t>
-                      </a:r>
-                    </a:p>
-                  </a:txBody>
-                  <a:tcPr>
-                    <a:solidFill>
-                      <a:srgbClr val="F0F4FF"/>
-                    </a:solidFill>
-                  </a:tcPr>
-                </a:tc>
-              </a:tr>
-              <a:tr h="279400">
-                <a:tc>
-                  <a:txBody>
-                    <a:bodyPr wrap="square"/>
-                    <a:lstStyle/>
-                    <a:p>
-                      <a:pPr algn="l"/>
-                      <a:r>
-                        <a:rPr sz="1000" b="0" i="0">
-                          <a:solidFill>
-                            <a:srgbClr val="2D3A6B"/>
-                          </a:solidFill>
-                          <a:latin typeface="Calibri"/>
-                        </a:rPr>
-                        <a:t>Vol shock +50%</a:t>
-                      </a:r>
-                    </a:p>
-                  </a:txBody>
-                  <a:tcPr>
-                    <a:solidFill>
-                      <a:srgbClr val="FFFFFF"/>
-                    </a:solidFill>
-                  </a:tcPr>
-                </a:tc>
-                <a:tc>
-                  <a:txBody>
-                    <a:bodyPr wrap="square"/>
-                    <a:lstStyle/>
-                    <a:p>
-                      <a:pPr algn="ctr"/>
-                      <a:r>
-                        <a:rPr sz="1000" b="0" i="0">
-                          <a:solidFill>
-                            <a:srgbClr val="2D3A6B"/>
-                          </a:solidFill>
-                          <a:latin typeface="Calibri"/>
-                        </a:rPr>
-                        <a:t>+0%</a:t>
-                      </a:r>
-                    </a:p>
-                  </a:txBody>
-                  <a:tcPr>
-                    <a:solidFill>
-                      <a:srgbClr val="FFFFFF"/>
-                    </a:solidFill>
-                  </a:tcPr>
-                </a:tc>
-                <a:tc>
-                  <a:txBody>
-                    <a:bodyPr wrap="square"/>
-                    <a:lstStyle/>
-                    <a:p>
-                      <a:pPr algn="ctr"/>
-                      <a:r>
-                        <a:rPr sz="1000" b="0" i="0">
-                          <a:solidFill>
-                            <a:srgbClr val="2D3A6B"/>
-                          </a:solidFill>
-                          <a:latin typeface="Calibri"/>
-                        </a:rPr>
-                        <a:t>+50%</a:t>
-                      </a:r>
-                    </a:p>
-                  </a:txBody>
-                  <a:tcPr>
-                    <a:solidFill>
-                      <a:srgbClr val="FFFFFF"/>
-                    </a:solidFill>
-                  </a:tcPr>
-                </a:tc>
-                <a:tc>
-                  <a:txBody>
-                    <a:bodyPr wrap="square"/>
-                    <a:lstStyle/>
-                    <a:p>
-                      <a:pPr algn="ctr"/>
-                      <a:r>
-                        <a:rPr sz="1000" b="0" i="0">
-                          <a:solidFill>
-                            <a:srgbClr val="2D3A6B"/>
-                          </a:solidFill>
-                          <a:latin typeface="Calibri"/>
-                        </a:rPr>
-                        <a:t>+$3,587</a:t>
-                      </a:r>
-                    </a:p>
-                  </a:txBody>
-                  <a:tcPr>
-                    <a:solidFill>
-                      <a:srgbClr val="FFFFFF"/>
-                    </a:solidFill>
-                  </a:tcPr>
-                </a:tc>
-                <a:tc>
-                  <a:txBody>
-                    <a:bodyPr wrap="square"/>
-                    <a:lstStyle/>
-                    <a:p>
-                      <a:pPr algn="ctr"/>
-                      <a:r>
-                        <a:rPr sz="1000" b="0" i="0">
-                          <a:solidFill>
-                            <a:srgbClr val="2D3A6B"/>
-                          </a:solidFill>
-                          <a:latin typeface="Calibri"/>
-                        </a:rPr>
-                        <a:t>+1.17%</a:t>
-                      </a:r>
-                    </a:p>
-                  </a:txBody>
-                  <a:tcPr>
-                    <a:solidFill>
-                      <a:srgbClr val="FFFFFF"/>
-                    </a:solidFill>
-                  </a:tcPr>
-                </a:tc>
-              </a:tr>
-              <a:tr h="279400">
-                <a:tc>
-                  <a:txBody>
-                    <a:bodyPr wrap="square"/>
-                    <a:lstStyle/>
-                    <a:p>
-                      <a:pPr algn="l"/>
-                      <a:r>
-                        <a:rPr sz="1000" b="0" i="0">
-                          <a:solidFill>
-                            <a:srgbClr val="2D3A6B"/>
-                          </a:solidFill>
-                          <a:latin typeface="Calibri"/>
-                        </a:rPr>
-                        <a:t>Crash (−15%, vol +50%)</a:t>
+                        <a:rPr sz="800" b="0" i="0">
+                          <a:solidFill>
+                            <a:srgbClr val="2D3A6B"/>
+                          </a:solidFill>
+                          <a:latin typeface="Calibri"/>
+                        </a:rPr>
+                        <a:t>Crash (−15%+50%vol)</a:t>
                       </a:r>
                     </a:p>
                   </a:txBody>
@@ -6834,13 +6024,13 @@
                     <a:p>
                       <a:pPr algn="ctr"/>
                       <a:r>
-                        <a:rPr sz="1000" b="0" i="0">
-                          <a:solidFill>
-                            <a:srgbClr val="2D3A6B"/>
-                          </a:solidFill>
-                          <a:latin typeface="Calibri"/>
-                        </a:rPr>
-                        <a:t>−15%</a:t>
+                        <a:rPr sz="800" b="0" i="0">
+                          <a:solidFill>
+                            <a:srgbClr val="2D3A6B"/>
+                          </a:solidFill>
+                          <a:latin typeface="Calibri"/>
+                        </a:rPr>
+                        <a:t>≈−$22,000</a:t>
                       </a:r>
                     </a:p>
                   </a:txBody>
@@ -6857,53 +6047,7 @@
                     <a:p>
                       <a:pPr algn="ctr"/>
                       <a:r>
-                        <a:rPr sz="1000" b="0" i="0">
-                          <a:solidFill>
-                            <a:srgbClr val="2D3A6B"/>
-                          </a:solidFill>
-                          <a:latin typeface="Calibri"/>
-                        </a:rPr>
-                        <a:t>+50%</a:t>
-                      </a:r>
-                    </a:p>
-                  </a:txBody>
-                  <a:tcPr>
-                    <a:solidFill>
-                      <a:srgbClr val="FFCCCC"/>
-                    </a:solidFill>
-                  </a:tcPr>
-                </a:tc>
-                <a:tc>
-                  <a:txBody>
-                    <a:bodyPr wrap="square"/>
-                    <a:lstStyle/>
-                    <a:p>
-                      <a:pPr algn="ctr"/>
-                      <a:r>
-                        <a:rPr sz="1000" b="0" i="0">
-                          <a:solidFill>
-                            <a:srgbClr val="2D3A6B"/>
-                          </a:solidFill>
-                          <a:latin typeface="Calibri"/>
-                        </a:rPr>
-                        <a:t>≈−$22,000</a:t>
-                      </a:r>
-                    </a:p>
-                  </a:txBody>
-                  <a:tcPr>
-                    <a:solidFill>
-                      <a:srgbClr val="FFCCCC"/>
-                    </a:solidFill>
-                  </a:tcPr>
-                </a:tc>
-                <a:tc>
-                  <a:txBody>
-                    <a:bodyPr wrap="square"/>
-                    <a:lstStyle/>
-                    <a:p>
-                      <a:pPr algn="ctr"/>
-                      <a:r>
-                        <a:rPr sz="1000" b="0" i="0">
+                        <a:rPr sz="800" b="0" i="0">
                           <a:solidFill>
                             <a:srgbClr val="2D3A6B"/>
                           </a:solidFill>
@@ -6924,49 +6068,30 @@
           </a:graphicData>
         </a:graphic>
       </p:graphicFrame>
-      <p:sp>
-        <p:nvSpPr>
-          <p:cNvPr id="7" name="Rectangle 6"/>
-          <p:cNvSpPr/>
+      <p:pic>
+        <p:nvPicPr>
+          <p:cNvPr id="7" name="Picture 6" descr="chart6_scenarios.png"/>
+          <p:cNvPicPr>
+            <a:picLocks noChangeAspect="1"/>
+          </p:cNvPicPr>
           <p:nvPr/>
-        </p:nvSpPr>
-        <p:spPr>
-          <a:xfrm>
-            <a:off x="228600" y="3630168"/>
-            <a:ext cx="8686800" cy="1234440"/>
+        </p:nvPicPr>
+        <p:blipFill>
+          <a:blip r:embed="rId2"/>
+          <a:stretch>
+            <a:fillRect/>
+          </a:stretch>
+        </p:blipFill>
+        <p:spPr>
+          <a:xfrm>
+            <a:off x="137160" y="987552"/>
+            <a:ext cx="5532120" cy="3383280"/>
           </a:xfrm>
           <a:prstGeom prst="rect">
             <a:avLst/>
           </a:prstGeom>
-          <a:solidFill>
-            <a:srgbClr val="E8EDFF"/>
-          </a:solidFill>
-          <a:ln>
-            <a:noFill/>
-          </a:ln>
-        </p:spPr>
-        <p:style>
-          <a:lnRef idx="1">
-            <a:schemeClr val="accent1"/>
-          </a:lnRef>
-          <a:fillRef idx="3">
-            <a:schemeClr val="accent1"/>
-          </a:fillRef>
-          <a:effectRef idx="2">
-            <a:schemeClr val="accent1"/>
-          </a:effectRef>
-          <a:fontRef idx="minor">
-            <a:schemeClr val="lt1"/>
-          </a:fontRef>
-        </p:style>
-        <p:txBody>
-          <a:bodyPr rtlCol="0" anchor="ctr"/>
-          <a:lstStyle/>
-          <a:p>
-            <a:pPr algn="ctr"/>
-          </a:p>
-        </p:txBody>
-      </p:sp>
+        </p:spPr>
+      </p:pic>
       <p:sp>
         <p:nvSpPr>
           <p:cNvPr id="8" name="TextBox 7"/>
@@ -6975,8 +6100,8 @@
         </p:nvSpPr>
         <p:spPr>
           <a:xfrm>
-            <a:off x="320040" y="3685032"/>
-            <a:ext cx="8412480" cy="228600"/>
+            <a:off x="228600" y="4434840"/>
+            <a:ext cx="8686800" cy="457200"/>
           </a:xfrm>
           <a:prstGeom prst="rect">
             <a:avLst/>
@@ -6989,48 +6114,14 @@
           <a:p>
             <a:pPr algn="l"/>
             <a:r>
-              <a:rPr sz="1000" b="1" i="0">
-                <a:solidFill>
-                  <a:srgbClr val="2D3A6B"/>
-                </a:solidFill>
-                <a:latin typeface="Calibri"/>
-              </a:rPr>
-              <a:t>Key Observations</a:t>
-            </a:r>
-          </a:p>
-        </p:txBody>
-      </p:sp>
-      <p:sp>
-        <p:nvSpPr>
-          <p:cNvPr id="9" name="TextBox 8"/>
-          <p:cNvSpPr txBox="1"/>
-          <p:nvPr/>
-        </p:nvSpPr>
-        <p:spPr>
-          <a:xfrm>
-            <a:off x="320040" y="3950208"/>
-            <a:ext cx="8412480" cy="822960"/>
-          </a:xfrm>
-          <a:prstGeom prst="rect">
-            <a:avLst/>
-          </a:prstGeom>
-          <a:noFill/>
-        </p:spPr>
-        <p:txBody>
-          <a:bodyPr wrap="square"/>
-          <a:lstStyle/>
-          <a:p>
-            <a:pPr algn="l"/>
-            <a:r>
-              <a:rPr sz="950" b="0" i="0">
+              <a:rPr sz="850" b="0" i="0">
                 <a:solidFill>
                   <a:srgbClr val="2D3A6B"/>
                 </a:solidFill>
                 <a:latin typeface="Calibri"/>
               </a:rPr>
               <a:t>•  Equity shocks dominate P&amp;L: ±20% spot ≈ ±$40–48k P&amp;L
-•  Vol shocks alone produce minimal P&amp;L — long CSL straddle (+V) offset by short BHP call (−V)
-•  Crash scenario: combined downside equity + vol spike approximates real crisis behaviour</a:t>
+•  Vol shocks alone are minimal — long CSL straddle offset by short BHP call</a:t>
             </a:r>
           </a:p>
         </p:txBody>
@@ -8465,8 +7556,8 @@
           <p:nvPr/>
         </p:nvGraphicFramePr>
         <p:xfrm>
-          <a:off x="228600" y="1005840"/>
-          <a:ext cx="8686800" cy="1143000"/>
+          <a:off x="228600" y="987552"/>
+          <a:ext cx="7772400" cy="1005840"/>
         </p:xfrm>
         <a:graphic>
           <a:graphicData uri="http://schemas.openxmlformats.org/drawingml/2006/table">
@@ -8475,20 +7566,20 @@
                 <a:tableStyleId>{5C22544A-7EE6-4342-B048-85BDC9FD1C3A}</a:tableStyleId>
               </a:tblPr>
               <a:tblGrid>
-                <a:gridCol w="3657600"/>
-                <a:gridCol w="1371600"/>
+                <a:gridCol w="3474720"/>
+                <a:gridCol w="1280160"/>
                 <a:gridCol w="1828800"/>
-                <a:gridCol w="1828800"/>
+                <a:gridCol w="1188720"/>
               </a:tblGrid>
-              <a:tr h="285750">
-                <a:tc>
-                  <a:txBody>
-                    <a:bodyPr wrap="square"/>
-                    <a:lstStyle/>
-                    <a:p>
-                      <a:pPr algn="ctr"/>
-                      <a:r>
-                        <a:rPr sz="1100" b="1" i="0">
+              <a:tr h="251460">
+                <a:tc>
+                  <a:txBody>
+                    <a:bodyPr wrap="square"/>
+                    <a:lstStyle/>
+                    <a:p>
+                      <a:pPr algn="ctr"/>
+                      <a:r>
+                        <a:rPr sz="1000" b="1" i="0">
                           <a:solidFill>
                             <a:srgbClr val="FFFFFF"/>
                           </a:solidFill>
@@ -8511,7 +7602,7 @@
                     <a:p>
                       <a:pPr algn="ctr"/>
                       <a:r>
-                        <a:rPr sz="1100" b="1" i="0">
+                        <a:rPr sz="1000" b="1" i="0">
                           <a:solidFill>
                             <a:srgbClr val="FFFFFF"/>
                           </a:solidFill>
@@ -8534,7 +7625,7 @@
                     <a:p>
                       <a:pPr algn="ctr"/>
                       <a:r>
-                        <a:rPr sz="1100" b="1" i="0">
+                        <a:rPr sz="1000" b="1" i="0">
                           <a:solidFill>
                             <a:srgbClr val="FFFFFF"/>
                           </a:solidFill>
@@ -8557,13 +7648,13 @@
                     <a:p>
                       <a:pPr algn="ctr"/>
                       <a:r>
-                        <a:rPr sz="1100" b="1" i="0">
+                        <a:rPr sz="1000" b="1" i="0">
                           <a:solidFill>
                             <a:srgbClr val="FFFFFF"/>
                           </a:solidFill>
                           <a:latin typeface="Calibri"/>
                         </a:rPr>
-                        <a:t>Captures Options?</a:t>
+                        <a:t>Options?</a:t>
                       </a:r>
                     </a:p>
                   </a:txBody>
@@ -8574,7 +7665,7 @@
                   </a:tcPr>
                 </a:tc>
               </a:tr>
-              <a:tr h="285750">
+              <a:tr h="251460">
                 <a:tc>
                   <a:txBody>
                     <a:bodyPr wrap="square"/>
@@ -8582,7 +7673,7 @@
                     <a:p>
                       <a:pPr algn="l"/>
                       <a:r>
-                        <a:rPr sz="1100" b="0" i="0">
+                        <a:rPr sz="1000" b="0" i="0">
                           <a:solidFill>
                             <a:srgbClr val="2D3A6B"/>
                           </a:solidFill>
@@ -8605,7 +7696,7 @@
                     <a:p>
                       <a:pPr algn="ctr"/>
                       <a:r>
-                        <a:rPr sz="1100" b="0" i="0">
+                        <a:rPr sz="1000" b="0" i="0">
                           <a:solidFill>
                             <a:srgbClr val="2D3A6B"/>
                           </a:solidFill>
@@ -8628,7 +7719,7 @@
                     <a:p>
                       <a:pPr algn="ctr"/>
                       <a:r>
-                        <a:rPr sz="1100" b="0" i="0">
+                        <a:rPr sz="1000" b="0" i="0">
                           <a:solidFill>
                             <a:srgbClr val="2D3A6B"/>
                           </a:solidFill>
@@ -8651,13 +7742,13 @@
                     <a:p>
                       <a:pPr algn="ctr"/>
                       <a:r>
-                        <a:rPr sz="1100" b="0" i="0">
-                          <a:solidFill>
-                            <a:srgbClr val="2D3A6B"/>
-                          </a:solidFill>
-                          <a:latin typeface="Calibri"/>
-                        </a:rPr>
-                        <a:t>No (linear approx)</a:t>
+                        <a:rPr sz="1000" b="0" i="0">
+                          <a:solidFill>
+                            <a:srgbClr val="2D3A6B"/>
+                          </a:solidFill>
+                          <a:latin typeface="Calibri"/>
+                        </a:rPr>
+                        <a:t>No</a:t>
                       </a:r>
                     </a:p>
                   </a:txBody>
@@ -8668,7 +7759,7 @@
                   </a:tcPr>
                 </a:tc>
               </a:tr>
-              <a:tr h="285750">
+              <a:tr h="251460">
                 <a:tc>
                   <a:txBody>
                     <a:bodyPr wrap="square"/>
@@ -8676,7 +7767,7 @@
                     <a:p>
                       <a:pPr algn="l"/>
                       <a:r>
-                        <a:rPr sz="1100" b="0" i="0">
+                        <a:rPr sz="1000" b="0" i="0">
                           <a:solidFill>
                             <a:srgbClr val="2D3A6B"/>
                           </a:solidFill>
@@ -8699,7 +7790,7 @@
                     <a:p>
                       <a:pPr algn="ctr"/>
                       <a:r>
-                        <a:rPr sz="1100" b="0" i="0">
+                        <a:rPr sz="1000" b="0" i="0">
                           <a:solidFill>
                             <a:srgbClr val="2D3A6B"/>
                           </a:solidFill>
@@ -8722,7 +7813,7 @@
                     <a:p>
                       <a:pPr algn="ctr"/>
                       <a:r>
-                        <a:rPr sz="1100" b="0" i="0">
+                        <a:rPr sz="1000" b="0" i="0">
                           <a:solidFill>
                             <a:srgbClr val="2D3A6B"/>
                           </a:solidFill>
@@ -8745,13 +7836,13 @@
                     <a:p>
                       <a:pPr algn="ctr"/>
                       <a:r>
-                        <a:rPr sz="1100" b="0" i="0">
-                          <a:solidFill>
-                            <a:srgbClr val="2D3A6B"/>
-                          </a:solidFill>
-                          <a:latin typeface="Calibri"/>
-                        </a:rPr>
-                        <a:t>Yes (full revaluation)</a:t>
+                        <a:rPr sz="1000" b="0" i="0">
+                          <a:solidFill>
+                            <a:srgbClr val="2D3A6B"/>
+                          </a:solidFill>
+                          <a:latin typeface="Calibri"/>
+                        </a:rPr>
+                        <a:t>Yes</a:t>
                       </a:r>
                     </a:p>
                   </a:txBody>
@@ -8762,7 +7853,7 @@
                   </a:tcPr>
                 </a:tc>
               </a:tr>
-              <a:tr h="285750">
+              <a:tr h="251460">
                 <a:tc>
                   <a:txBody>
                     <a:bodyPr wrap="square"/>
@@ -8770,7 +7861,7 @@
                     <a:p>
                       <a:pPr algn="l"/>
                       <a:r>
-                        <a:rPr sz="1100" b="1" i="0">
+                        <a:rPr sz="1000" b="1" i="0">
                           <a:solidFill>
                             <a:srgbClr val="5B8DEF"/>
                           </a:solidFill>
@@ -8793,7 +7884,7 @@
                     <a:p>
                       <a:pPr algn="ctr"/>
                       <a:r>
-                        <a:rPr sz="1100" b="1" i="0">
+                        <a:rPr sz="1000" b="1" i="0">
                           <a:solidFill>
                             <a:srgbClr val="5B8DEF"/>
                           </a:solidFill>
@@ -8816,7 +7907,7 @@
                     <a:p>
                       <a:pPr algn="ctr"/>
                       <a:r>
-                        <a:rPr sz="1100" b="1" i="0">
+                        <a:rPr sz="1000" b="1" i="0">
                           <a:solidFill>
                             <a:srgbClr val="5B8DEF"/>
                           </a:solidFill>
@@ -8839,7 +7930,7 @@
                     <a:p>
                       <a:pPr algn="ctr"/>
                       <a:r>
-                        <a:rPr sz="1100" b="1" i="0">
+                        <a:rPr sz="1000" b="1" i="0">
                           <a:solidFill>
                             <a:srgbClr val="5B8DEF"/>
                           </a:solidFill>
@@ -8860,366 +7951,30 @@
           </a:graphicData>
         </a:graphic>
       </p:graphicFrame>
-      <p:sp>
-        <p:nvSpPr>
-          <p:cNvPr id="7" name="Rectangle 6"/>
-          <p:cNvSpPr/>
+      <p:pic>
+        <p:nvPicPr>
+          <p:cNvPr id="7" name="Picture 6" descr="chart7_drawdown.png"/>
+          <p:cNvPicPr>
+            <a:picLocks noChangeAspect="1"/>
+          </p:cNvPicPr>
           <p:nvPr/>
-        </p:nvSpPr>
-        <p:spPr>
-          <a:xfrm>
-            <a:off x="228600" y="2240280"/>
-            <a:ext cx="8686800" cy="914400"/>
+        </p:nvPicPr>
+        <p:blipFill>
+          <a:blip r:embed="rId2"/>
+          <a:stretch>
+            <a:fillRect/>
+          </a:stretch>
+        </p:blipFill>
+        <p:spPr>
+          <a:xfrm>
+            <a:off x="137160" y="2057400"/>
+            <a:ext cx="8869680" cy="2880360"/>
           </a:xfrm>
           <a:prstGeom prst="rect">
             <a:avLst/>
           </a:prstGeom>
-          <a:solidFill>
-            <a:srgbClr val="2D3A6B"/>
-          </a:solidFill>
-          <a:ln>
-            <a:noFill/>
-          </a:ln>
-        </p:spPr>
-        <p:style>
-          <a:lnRef idx="1">
-            <a:schemeClr val="accent1"/>
-          </a:lnRef>
-          <a:fillRef idx="3">
-            <a:schemeClr val="accent1"/>
-          </a:fillRef>
-          <a:effectRef idx="2">
-            <a:schemeClr val="accent1"/>
-          </a:effectRef>
-          <a:fontRef idx="minor">
-            <a:schemeClr val="lt1"/>
-          </a:fontRef>
-        </p:style>
-        <p:txBody>
-          <a:bodyPr rtlCol="0" anchor="ctr"/>
-          <a:lstStyle/>
-          <a:p>
-            <a:pPr algn="ctr"/>
-          </a:p>
-        </p:txBody>
-      </p:sp>
-      <p:sp>
-        <p:nvSpPr>
-          <p:cNvPr id="8" name="TextBox 7"/>
-          <p:cNvSpPr txBox="1"/>
-          <p:nvPr/>
-        </p:nvSpPr>
-        <p:spPr>
-          <a:xfrm>
-            <a:off x="320040" y="2313432"/>
-            <a:ext cx="1371600" cy="274320"/>
-          </a:xfrm>
-          <a:prstGeom prst="rect">
-            <a:avLst/>
-          </a:prstGeom>
-          <a:noFill/>
-        </p:spPr>
-        <p:txBody>
-          <a:bodyPr wrap="square"/>
-          <a:lstStyle/>
-          <a:p>
-            <a:pPr algn="l"/>
-            <a:r>
-              <a:rPr sz="1100" b="1" i="0">
-                <a:solidFill>
-                  <a:srgbClr val="5B8DEF"/>
-                </a:solidFill>
-                <a:latin typeface="Calibri"/>
-              </a:rPr>
-              <a:t>Key Insight:</a:t>
-            </a:r>
-          </a:p>
-        </p:txBody>
-      </p:sp>
-      <p:sp>
-        <p:nvSpPr>
-          <p:cNvPr id="9" name="TextBox 8"/>
-          <p:cNvSpPr txBox="1"/>
-          <p:nvPr/>
-        </p:nvSpPr>
-        <p:spPr>
-          <a:xfrm>
-            <a:off x="320040" y="2587752"/>
-            <a:ext cx="8321040" cy="502920"/>
-          </a:xfrm>
-          <a:prstGeom prst="rect">
-            <a:avLst/>
-          </a:prstGeom>
-          <a:noFill/>
-        </p:spPr>
-        <p:txBody>
-          <a:bodyPr wrap="square"/>
-          <a:lstStyle/>
-          <a:p>
-            <a:pPr algn="l"/>
-            <a:r>
-              <a:rPr sz="1000" b="0" i="0">
-                <a:solidFill>
-                  <a:srgbClr val="FFFFFF"/>
-                </a:solidFill>
-                <a:latin typeface="Calibri"/>
-              </a:rPr>
-              <a:t>The option overlays — primarily the CBA protective put — empirically reduce historical drawdown by 61.5%. This is not theoretical; it is observed in the historical price path.</a:t>
-            </a:r>
-          </a:p>
-        </p:txBody>
-      </p:sp>
-      <p:sp>
-        <p:nvSpPr>
-          <p:cNvPr id="10" name="TextBox 9"/>
-          <p:cNvSpPr txBox="1"/>
-          <p:nvPr/>
-        </p:nvSpPr>
-        <p:spPr>
-          <a:xfrm>
-            <a:off x="228600" y="3246120"/>
-            <a:ext cx="8686800" cy="274320"/>
-          </a:xfrm>
-          <a:prstGeom prst="rect">
-            <a:avLst/>
-          </a:prstGeom>
-          <a:noFill/>
-        </p:spPr>
-        <p:txBody>
-          <a:bodyPr wrap="square"/>
-          <a:lstStyle/>
-          <a:p>
-            <a:pPr algn="l"/>
-            <a:r>
-              <a:rPr sz="1100" b="1" i="0">
-                <a:solidFill>
-                  <a:srgbClr val="2D3A6B"/>
-                </a:solidFill>
-                <a:latin typeface="Calibri"/>
-              </a:rPr>
-              <a:t>Dollar MDD Comparison</a:t>
-            </a:r>
-          </a:p>
-        </p:txBody>
-      </p:sp>
-      <p:sp>
-        <p:nvSpPr>
-          <p:cNvPr id="11" name="Rectangle 10"/>
-          <p:cNvSpPr/>
-          <p:nvPr/>
-        </p:nvSpPr>
-        <p:spPr>
-          <a:xfrm>
-            <a:off x="1828800" y="3538728"/>
-            <a:ext cx="6400800" cy="365760"/>
-          </a:xfrm>
-          <a:prstGeom prst="rect">
-            <a:avLst/>
-          </a:prstGeom>
-          <a:solidFill>
-            <a:srgbClr val="2D3A6B"/>
-          </a:solidFill>
-          <a:ln>
-            <a:noFill/>
-          </a:ln>
-        </p:spPr>
-        <p:style>
-          <a:lnRef idx="1">
-            <a:schemeClr val="accent1"/>
-          </a:lnRef>
-          <a:fillRef idx="3">
-            <a:schemeClr val="accent1"/>
-          </a:fillRef>
-          <a:effectRef idx="2">
-            <a:schemeClr val="accent1"/>
-          </a:effectRef>
-          <a:fontRef idx="minor">
-            <a:schemeClr val="lt1"/>
-          </a:fontRef>
-        </p:style>
-        <p:txBody>
-          <a:bodyPr rtlCol="0" anchor="ctr"/>
-          <a:lstStyle/>
-          <a:p>
-            <a:pPr algn="ctr"/>
-          </a:p>
-        </p:txBody>
-      </p:sp>
-      <p:sp>
-        <p:nvSpPr>
-          <p:cNvPr id="12" name="TextBox 11"/>
-          <p:cNvSpPr txBox="1"/>
-          <p:nvPr/>
-        </p:nvSpPr>
-        <p:spPr>
-          <a:xfrm>
-            <a:off x="228600" y="3593592"/>
-            <a:ext cx="1554480" cy="365760"/>
-          </a:xfrm>
-          <a:prstGeom prst="rect">
-            <a:avLst/>
-          </a:prstGeom>
-          <a:noFill/>
-        </p:spPr>
-        <p:txBody>
-          <a:bodyPr wrap="square"/>
-          <a:lstStyle/>
-          <a:p>
-            <a:pPr algn="l"/>
-            <a:r>
-              <a:rPr sz="900" b="0" i="0">
-                <a:solidFill>
-                  <a:srgbClr val="2D3A6B"/>
-                </a:solidFill>
-                <a:latin typeface="Calibri"/>
-              </a:rPr>
-              <a:t>Equity equiv.</a:t>
-            </a:r>
-          </a:p>
-        </p:txBody>
-      </p:sp>
-      <p:sp>
-        <p:nvSpPr>
-          <p:cNvPr id="13" name="TextBox 12"/>
-          <p:cNvSpPr txBox="1"/>
-          <p:nvPr/>
-        </p:nvSpPr>
-        <p:spPr>
-          <a:xfrm>
-            <a:off x="8275320" y="3593592"/>
-            <a:ext cx="1371600" cy="365760"/>
-          </a:xfrm>
-          <a:prstGeom prst="rect">
-            <a:avLst/>
-          </a:prstGeom>
-          <a:noFill/>
-        </p:spPr>
-        <p:txBody>
-          <a:bodyPr wrap="square"/>
-          <a:lstStyle/>
-          <a:p>
-            <a:pPr algn="l"/>
-            <a:r>
-              <a:rPr sz="900" b="1" i="0">
-                <a:solidFill>
-                  <a:srgbClr val="2D3A6B"/>
-                </a:solidFill>
-                <a:latin typeface="Calibri"/>
-              </a:rPr>
-              <a:t>$70,224</a:t>
-            </a:r>
-          </a:p>
-        </p:txBody>
-      </p:sp>
-      <p:sp>
-        <p:nvSpPr>
-          <p:cNvPr id="14" name="Rectangle 13"/>
-          <p:cNvSpPr/>
-          <p:nvPr/>
-        </p:nvSpPr>
-        <p:spPr>
-          <a:xfrm>
-            <a:off x="1828800" y="4023360"/>
-            <a:ext cx="3323267" cy="365760"/>
-          </a:xfrm>
-          <a:prstGeom prst="rect">
-            <a:avLst/>
-          </a:prstGeom>
-          <a:solidFill>
-            <a:srgbClr val="5B8DEF"/>
-          </a:solidFill>
-          <a:ln>
-            <a:noFill/>
-          </a:ln>
-        </p:spPr>
-        <p:style>
-          <a:lnRef idx="1">
-            <a:schemeClr val="accent1"/>
-          </a:lnRef>
-          <a:fillRef idx="3">
-            <a:schemeClr val="accent1"/>
-          </a:fillRef>
-          <a:effectRef idx="2">
-            <a:schemeClr val="accent1"/>
-          </a:effectRef>
-          <a:fontRef idx="minor">
-            <a:schemeClr val="lt1"/>
-          </a:fontRef>
-        </p:style>
-        <p:txBody>
-          <a:bodyPr rtlCol="0" anchor="ctr"/>
-          <a:lstStyle/>
-          <a:p>
-            <a:pPr algn="ctr"/>
-          </a:p>
-        </p:txBody>
-      </p:sp>
-      <p:sp>
-        <p:nvSpPr>
-          <p:cNvPr id="15" name="TextBox 14"/>
-          <p:cNvSpPr txBox="1"/>
-          <p:nvPr/>
-        </p:nvSpPr>
-        <p:spPr>
-          <a:xfrm>
-            <a:off x="228600" y="4078224"/>
-            <a:ext cx="1554480" cy="365760"/>
-          </a:xfrm>
-          <a:prstGeom prst="rect">
-            <a:avLst/>
-          </a:prstGeom>
-          <a:noFill/>
-        </p:spPr>
-        <p:txBody>
-          <a:bodyPr wrap="square"/>
-          <a:lstStyle/>
-          <a:p>
-            <a:pPr algn="l"/>
-            <a:r>
-              <a:rPr sz="900" b="0" i="0">
-                <a:solidFill>
-                  <a:srgbClr val="2D3A6B"/>
-                </a:solidFill>
-                <a:latin typeface="Calibri"/>
-              </a:rPr>
-              <a:t>Full portfolio</a:t>
-            </a:r>
-          </a:p>
-        </p:txBody>
-      </p:sp>
-      <p:sp>
-        <p:nvSpPr>
-          <p:cNvPr id="16" name="TextBox 15"/>
-          <p:cNvSpPr txBox="1"/>
-          <p:nvPr/>
-        </p:nvSpPr>
-        <p:spPr>
-          <a:xfrm>
-            <a:off x="5197787" y="4078224"/>
-            <a:ext cx="1371600" cy="365760"/>
-          </a:xfrm>
-          <a:prstGeom prst="rect">
-            <a:avLst/>
-          </a:prstGeom>
-          <a:noFill/>
-        </p:spPr>
-        <p:txBody>
-          <a:bodyPr wrap="square"/>
-          <a:lstStyle/>
-          <a:p>
-            <a:pPr algn="l"/>
-            <a:r>
-              <a:rPr sz="900" b="1" i="0">
-                <a:solidFill>
-                  <a:srgbClr val="5B8DEF"/>
-                </a:solidFill>
-                <a:latin typeface="Calibri"/>
-              </a:rPr>
-              <a:t>$36,460  (−61.5%)</a:t>
-            </a:r>
-          </a:p>
-        </p:txBody>
-      </p:sp>
+        </p:spPr>
+      </p:pic>
     </p:spTree>
   </p:cSld>
   <p:clrMapOvr>
@@ -10969,7 +9724,7 @@
         <p:spPr>
           <a:xfrm>
             <a:off x="182880" y="1005840"/>
-            <a:ext cx="2788920" cy="320040"/>
+            <a:ext cx="4023360" cy="320040"/>
           </a:xfrm>
           <a:prstGeom prst="rect">
             <a:avLst/>
@@ -11012,7 +9767,7 @@
         <p:spPr>
           <a:xfrm>
             <a:off x="182880" y="1325880"/>
-            <a:ext cx="2788920" cy="3383280"/>
+            <a:ext cx="4023360" cy="1508760"/>
           </a:xfrm>
           <a:prstGeom prst="rect">
             <a:avLst/>
@@ -11055,7 +9810,7 @@
         <p:spPr>
           <a:xfrm>
             <a:off x="228600" y="1033272"/>
-            <a:ext cx="2697480" cy="274320"/>
+            <a:ext cx="3931920" cy="274320"/>
           </a:xfrm>
           <a:prstGeom prst="rect">
             <a:avLst/>
@@ -11090,7 +9845,7 @@
         <p:spPr>
           <a:xfrm>
             <a:off x="256032" y="1353312"/>
-            <a:ext cx="2679192" cy="3291840"/>
+            <a:ext cx="3913632" cy="1417320"/>
           </a:xfrm>
           <a:prstGeom prst="rect">
             <a:avLst/>
@@ -11104,16 +9859,14 @@
           <a:lstStyle/>
           <a:p>
             <a:r>
-              <a:rPr sz="1000">
+              <a:rPr sz="900">
                 <a:solidFill>
                   <a:srgbClr val="2D3A6B"/>
                 </a:solidFill>
                 <a:latin typeface="Calibri"/>
               </a:rPr>
               <a:t>Source: RBA F17 zero-coupon rates
-Date: 30-04-2026
-Maturities: 41 points
-(0yr to 10yr, 0.25yr increments)
+Date: 30-04-2026  |  41 maturities (0–10yr, 0.25yr steps)
 Period: 2017-01-03 to 2026-04-30</a:t>
             </a:r>
           </a:p>
@@ -11127,14 +9880,14 @@
         </p:nvSpPr>
         <p:spPr>
           <a:xfrm>
-            <a:off x="3108960" y="1005840"/>
-            <a:ext cx="2788920" cy="320040"/>
+            <a:off x="182880" y="2907792"/>
+            <a:ext cx="4023360" cy="320040"/>
           </a:xfrm>
           <a:prstGeom prst="rect">
             <a:avLst/>
           </a:prstGeom>
           <a:solidFill>
-            <a:srgbClr val="5B8DEF"/>
+            <a:srgbClr val="2D3A6B"/>
           </a:solidFill>
           <a:ln>
             <a:noFill/>
@@ -11170,8 +9923,8 @@
         </p:nvSpPr>
         <p:spPr>
           <a:xfrm>
-            <a:off x="3108960" y="1325880"/>
-            <a:ext cx="2788920" cy="3383280"/>
+            <a:off x="182880" y="3227832"/>
+            <a:ext cx="4023360" cy="1508760"/>
           </a:xfrm>
           <a:prstGeom prst="rect">
             <a:avLst/>
@@ -11213,8 +9966,8 @@
         </p:nvSpPr>
         <p:spPr>
           <a:xfrm>
-            <a:off x="3154680" y="1033272"/>
-            <a:ext cx="2697480" cy="274320"/>
+            <a:off x="228600" y="2935224"/>
+            <a:ext cx="3931920" cy="274320"/>
           </a:xfrm>
           <a:prstGeom prst="rect">
             <a:avLst/>
@@ -11235,7 +9988,7 @@
                 </a:solidFill>
                 <a:latin typeface="Calibri"/>
               </a:rPr>
-              <a:t>Interpolation &amp; Compounding</a:t>
+              <a:t>Risk-Free Rates r (continuous, from zero-coupon strip)</a:t>
             </a:r>
           </a:p>
         </p:txBody>
@@ -11248,8 +10001,8 @@
         </p:nvSpPr>
         <p:spPr>
           <a:xfrm>
-            <a:off x="3182112" y="1353312"/>
-            <a:ext cx="2679192" cy="3291840"/>
+            <a:off x="256032" y="3255264"/>
+            <a:ext cx="3913632" cy="1417320"/>
           </a:xfrm>
           <a:prstGeom prst="rect">
             <a:avLst/>
@@ -11263,167 +10016,7 @@
           <a:lstStyle/>
           <a:p>
             <a:r>
-              <a:rPr sz="1000">
-                <a:solidFill>
-                  <a:srgbClr val="2D3A6B"/>
-                </a:solidFill>
-                <a:latin typeface="Calibri"/>
-              </a:rPr>
-              <a:t>Method: Linear (default) or Cubic Spline
-Max difference: 0.56bp (immaterial)
-Compounding: Continuous
-Cubic: smoother, better for
-long-dated instruments
-Linear: sufficient for 6m options</a:t>
-            </a:r>
-          </a:p>
-        </p:txBody>
-      </p:sp>
-      <p:sp>
-        <p:nvSpPr>
-          <p:cNvPr id="14" name="Rectangle 13"/>
-          <p:cNvSpPr/>
-          <p:nvPr/>
-        </p:nvSpPr>
-        <p:spPr>
-          <a:xfrm>
-            <a:off x="6035040" y="1005840"/>
-            <a:ext cx="2788920" cy="320040"/>
-          </a:xfrm>
-          <a:prstGeom prst="rect">
-            <a:avLst/>
-          </a:prstGeom>
-          <a:solidFill>
-            <a:srgbClr val="2D3A6B"/>
-          </a:solidFill>
-          <a:ln>
-            <a:noFill/>
-          </a:ln>
-        </p:spPr>
-        <p:style>
-          <a:lnRef idx="1">
-            <a:schemeClr val="accent1"/>
-          </a:lnRef>
-          <a:fillRef idx="3">
-            <a:schemeClr val="accent1"/>
-          </a:fillRef>
-          <a:effectRef idx="2">
-            <a:schemeClr val="accent1"/>
-          </a:effectRef>
-          <a:fontRef idx="minor">
-            <a:schemeClr val="lt1"/>
-          </a:fontRef>
-        </p:style>
-        <p:txBody>
-          <a:bodyPr rtlCol="0" anchor="ctr"/>
-          <a:lstStyle/>
-          <a:p>
-            <a:pPr algn="ctr"/>
-          </a:p>
-        </p:txBody>
-      </p:sp>
-      <p:sp>
-        <p:nvSpPr>
-          <p:cNvPr id="15" name="Rectangle 14"/>
-          <p:cNvSpPr/>
-          <p:nvPr/>
-        </p:nvSpPr>
-        <p:spPr>
-          <a:xfrm>
-            <a:off x="6035040" y="1325880"/>
-            <a:ext cx="2788920" cy="914400"/>
-          </a:xfrm>
-          <a:prstGeom prst="rect">
-            <a:avLst/>
-          </a:prstGeom>
-          <a:solidFill>
-            <a:srgbClr val="F0F4FF"/>
-          </a:solidFill>
-          <a:ln>
-            <a:noFill/>
-          </a:ln>
-        </p:spPr>
-        <p:style>
-          <a:lnRef idx="1">
-            <a:schemeClr val="accent1"/>
-          </a:lnRef>
-          <a:fillRef idx="3">
-            <a:schemeClr val="accent1"/>
-          </a:fillRef>
-          <a:effectRef idx="2">
-            <a:schemeClr val="accent1"/>
-          </a:effectRef>
-          <a:fontRef idx="minor">
-            <a:schemeClr val="lt1"/>
-          </a:fontRef>
-        </p:style>
-        <p:txBody>
-          <a:bodyPr rtlCol="0" anchor="ctr"/>
-          <a:lstStyle/>
-          <a:p>
-            <a:pPr algn="ctr"/>
-          </a:p>
-        </p:txBody>
-      </p:sp>
-      <p:sp>
-        <p:nvSpPr>
-          <p:cNvPr id="16" name="TextBox 15"/>
-          <p:cNvSpPr txBox="1"/>
-          <p:nvPr/>
-        </p:nvSpPr>
-        <p:spPr>
-          <a:xfrm>
-            <a:off x="6080760" y="1033272"/>
-            <a:ext cx="2697480" cy="274320"/>
-          </a:xfrm>
-          <a:prstGeom prst="rect">
-            <a:avLst/>
-          </a:prstGeom>
-          <a:noFill/>
-        </p:spPr>
-        <p:txBody>
-          <a:bodyPr wrap="none">
-            <a:spAutoFit/>
-          </a:bodyPr>
-          <a:lstStyle/>
-          <a:p>
-            <a:pPr algn="l"/>
-            <a:r>
-              <a:rPr sz="1200" b="1">
-                <a:solidFill>
-                  <a:srgbClr val="FFFFFF"/>
-                </a:solidFill>
-                <a:latin typeface="Calibri"/>
-              </a:rPr>
-              <a:t>Risk-Free Rates (r)</a:t>
-            </a:r>
-          </a:p>
-        </p:txBody>
-      </p:sp>
-      <p:sp>
-        <p:nvSpPr>
-          <p:cNvPr id="17" name="TextBox 16"/>
-          <p:cNvSpPr txBox="1"/>
-          <p:nvPr/>
-        </p:nvSpPr>
-        <p:spPr>
-          <a:xfrm>
-            <a:off x="6108192" y="1353312"/>
-            <a:ext cx="2679192" cy="822960"/>
-          </a:xfrm>
-          <a:prstGeom prst="rect">
-            <a:avLst/>
-          </a:prstGeom>
-          <a:noFill/>
-        </p:spPr>
-        <p:txBody>
-          <a:bodyPr wrap="square">
-            <a:spAutoFit/>
-          </a:bodyPr>
-          <a:lstStyle/>
-          <a:p>
-            <a:r>
-              <a:rPr sz="1000">
+              <a:rPr sz="900">
                 <a:solidFill>
                   <a:srgbClr val="2D3A6B"/>
                 </a:solidFill>
@@ -11436,15 +10029,15 @@
       </p:sp>
       <p:graphicFrame>
         <p:nvGraphicFramePr>
-          <p:cNvPr id="18" name="Table 17"/>
+          <p:cNvPr id="14" name="Table 13"/>
           <p:cNvGraphicFramePr>
             <a:graphicFrameLocks noGrp="1"/>
           </p:cNvGraphicFramePr>
           <p:nvPr/>
         </p:nvGraphicFramePr>
         <p:xfrm>
-          <a:off x="6080760" y="1399032"/>
-          <a:ext cx="2697480" cy="2423160"/>
+          <a:off x="228600" y="3255264"/>
+          <a:ext cx="3931920" cy="1417320"/>
         </p:xfrm>
         <a:graphic>
           <a:graphicData uri="http://schemas.openxmlformats.org/drawingml/2006/table">
@@ -11453,11 +10046,11 @@
                 <a:tableStyleId>{5C22544A-7EE6-4342-B048-85BDC9FD1C3A}</a:tableStyleId>
               </a:tblPr>
               <a:tblGrid>
-                <a:gridCol w="899160"/>
-                <a:gridCol w="899160"/>
-                <a:gridCol w="899160"/>
+                <a:gridCol w="1310640"/>
+                <a:gridCol w="1310640"/>
+                <a:gridCol w="1310640"/>
               </a:tblGrid>
-              <a:tr h="484632">
+              <a:tr h="283464">
                 <a:tc>
                   <a:txBody>
                     <a:bodyPr wrap="square"/>
@@ -11528,7 +10121,7 @@
                   </a:tcPr>
                 </a:tc>
               </a:tr>
-              <a:tr h="484632">
+              <a:tr h="283464">
                 <a:tc>
                   <a:txBody>
                     <a:bodyPr wrap="square"/>
@@ -11599,7 +10192,7 @@
                   </a:tcPr>
                 </a:tc>
               </a:tr>
-              <a:tr h="484632">
+              <a:tr h="283464">
                 <a:tc>
                   <a:txBody>
                     <a:bodyPr wrap="square"/>
@@ -11670,7 +10263,7 @@
                   </a:tcPr>
                 </a:tc>
               </a:tr>
-              <a:tr h="484632">
+              <a:tr h="283464">
                 <a:tc>
                   <a:txBody>
                     <a:bodyPr wrap="square"/>
@@ -11741,7 +10334,7 @@
                   </a:tcPr>
                 </a:tc>
               </a:tr>
-              <a:tr h="484632">
+              <a:tr h="283464">
                 <a:tc>
                   <a:txBody>
                     <a:bodyPr wrap="square"/>
@@ -11816,39 +10409,30 @@
           </a:graphicData>
         </a:graphic>
       </p:graphicFrame>
-      <p:sp>
-        <p:nvSpPr>
-          <p:cNvPr id="19" name="TextBox 18"/>
-          <p:cNvSpPr txBox="1"/>
+      <p:pic>
+        <p:nvPicPr>
+          <p:cNvPr id="15" name="Picture 14" descr="chart1_yield_curve.png"/>
+          <p:cNvPicPr>
+            <a:picLocks noChangeAspect="1"/>
+          </p:cNvPicPr>
           <p:nvPr/>
-        </p:nvSpPr>
-        <p:spPr>
-          <a:xfrm>
-            <a:off x="6080760" y="3840480"/>
-            <a:ext cx="2697480" cy="411480"/>
+        </p:nvPicPr>
+        <p:blipFill>
+          <a:blip r:embed="rId2"/>
+          <a:stretch>
+            <a:fillRect/>
+          </a:stretch>
+        </p:blipFill>
+        <p:spPr>
+          <a:xfrm>
+            <a:off x="4297680" y="1005840"/>
+            <a:ext cx="4663440" cy="3749039"/>
           </a:xfrm>
           <a:prstGeom prst="rect">
             <a:avLst/>
           </a:prstGeom>
-          <a:noFill/>
-        </p:spPr>
-        <p:txBody>
-          <a:bodyPr wrap="square"/>
-          <a:lstStyle/>
-          <a:p>
-            <a:pPr algn="l"/>
-            <a:r>
-              <a:rPr sz="800" b="0" i="1">
-                <a:solidFill>
-                  <a:srgbClr val="2D3A6B"/>
-                </a:solidFill>
-                <a:latin typeface="Calibri"/>
-              </a:rPr>
-              <a:t>Continuous compounding: r from zero-coupon strip</a:t>
-            </a:r>
-          </a:p>
-        </p:txBody>
-      </p:sp>
+        </p:spPr>
+      </p:pic>
     </p:spTree>
   </p:cSld>
   <p:clrMapOvr>
@@ -13049,7 +11633,7 @@
         </p:nvGraphicFramePr>
         <p:xfrm>
           <a:off x="137160" y="987552"/>
-          <a:ext cx="7955280" cy="1554480"/>
+          <a:ext cx="7955280" cy="1417320"/>
         </p:xfrm>
         <a:graphic>
           <a:graphicData uri="http://schemas.openxmlformats.org/drawingml/2006/table">
@@ -13068,7 +11652,7 @@
                 <a:gridCol w="822960"/>
                 <a:gridCol w="822960"/>
               </a:tblGrid>
-              <a:tr h="310896">
+              <a:tr h="283464">
                 <a:tc>
                   <a:txBody>
                     <a:bodyPr wrap="square"/>
@@ -13277,7 +11861,7 @@
                   </a:tcPr>
                 </a:tc>
               </a:tr>
-              <a:tr h="310896">
+              <a:tr h="283464">
                 <a:tc>
                   <a:txBody>
                     <a:bodyPr wrap="square"/>
@@ -13486,7 +12070,7 @@
                   </a:tcPr>
                 </a:tc>
               </a:tr>
-              <a:tr h="310896">
+              <a:tr h="283464">
                 <a:tc>
                   <a:txBody>
                     <a:bodyPr wrap="square"/>
@@ -13695,7 +12279,7 @@
                   </a:tcPr>
                 </a:tc>
               </a:tr>
-              <a:tr h="310896">
+              <a:tr h="283464">
                 <a:tc>
                   <a:txBody>
                     <a:bodyPr wrap="square"/>
@@ -13904,7 +12488,7 @@
                   </a:tcPr>
                 </a:tc>
               </a:tr>
-              <a:tr h="310896">
+              <a:tr h="283464">
                 <a:tc>
                   <a:txBody>
                     <a:bodyPr wrap="square"/>
@@ -14117,207 +12701,30 @@
           </a:graphicData>
         </a:graphic>
       </p:graphicFrame>
-      <p:sp>
-        <p:nvSpPr>
-          <p:cNvPr id="7" name="TextBox 6"/>
-          <p:cNvSpPr txBox="1"/>
+      <p:pic>
+        <p:nvPicPr>
+          <p:cNvPr id="7" name="Picture 6" descr="chart2_option_convergence.png"/>
+          <p:cNvPicPr>
+            <a:picLocks noChangeAspect="1"/>
+          </p:cNvPicPr>
           <p:nvPr/>
-        </p:nvSpPr>
-        <p:spPr>
-          <a:xfrm>
-            <a:off x="182880" y="2697480"/>
-            <a:ext cx="1828800" cy="475488"/>
+        </p:nvPicPr>
+        <p:blipFill>
+          <a:blip r:embed="rId2"/>
+          <a:stretch>
+            <a:fillRect/>
+          </a:stretch>
+        </p:blipFill>
+        <p:spPr>
+          <a:xfrm>
+            <a:off x="137160" y="2468880"/>
+            <a:ext cx="8869680" cy="2514600"/>
           </a:xfrm>
           <a:prstGeom prst="rect">
             <a:avLst/>
           </a:prstGeom>
-          <a:noFill/>
-        </p:spPr>
-        <p:txBody>
-          <a:bodyPr wrap="none">
-            <a:spAutoFit/>
-          </a:bodyPr>
-          <a:lstStyle/>
-          <a:p>
-            <a:r>
-              <a:rPr sz="900" b="1">
-                <a:solidFill>
-                  <a:srgbClr val="5B8DEF"/>
-                </a:solidFill>
-                <a:latin typeface="Calibri"/>
-              </a:rPr>
-              <a:t>1.  Merton Extension:</a:t>
-            </a:r>
-          </a:p>
-        </p:txBody>
-      </p:sp>
-      <p:sp>
-        <p:nvSpPr>
-          <p:cNvPr id="8" name="TextBox 7"/>
-          <p:cNvSpPr txBox="1"/>
-          <p:nvPr/>
-        </p:nvSpPr>
-        <p:spPr>
-          <a:xfrm>
-            <a:off x="2011680" y="2697480"/>
-            <a:ext cx="6949440" cy="475488"/>
-          </a:xfrm>
-          <a:prstGeom prst="rect">
-            <a:avLst/>
-          </a:prstGeom>
-          <a:noFill/>
-        </p:spPr>
-        <p:txBody>
-          <a:bodyPr wrap="square"/>
-          <a:lstStyle/>
-          <a:p>
-            <a:pPr algn="l"/>
-            <a:r>
-              <a:rPr sz="900" b="0" i="0">
-                <a:solidFill>
-                  <a:srgbClr val="2D3A6B"/>
-                </a:solidFill>
-                <a:latin typeface="Calibri"/>
-              </a:rPr>
-              <a:t>Continuous dividend yield q applied to all ASX stocks. Without this, calls are overpriced and puts underpriced.</a:t>
-            </a:r>
-          </a:p>
-        </p:txBody>
-      </p:sp>
-      <p:sp>
-        <p:nvSpPr>
-          <p:cNvPr id="9" name="TextBox 8"/>
-          <p:cNvSpPr txBox="1"/>
-          <p:nvPr/>
-        </p:nvSpPr>
-        <p:spPr>
-          <a:xfrm>
-            <a:off x="182880" y="3227832"/>
-            <a:ext cx="1828800" cy="475488"/>
-          </a:xfrm>
-          <a:prstGeom prst="rect">
-            <a:avLst/>
-          </a:prstGeom>
-          <a:noFill/>
-        </p:spPr>
-        <p:txBody>
-          <a:bodyPr wrap="none">
-            <a:spAutoFit/>
-          </a:bodyPr>
-          <a:lstStyle/>
-          <a:p>
-            <a:r>
-              <a:rPr sz="900" b="1">
-                <a:solidFill>
-                  <a:srgbClr val="5B8DEF"/>
-                </a:solidFill>
-                <a:latin typeface="Calibri"/>
-              </a:rPr>
-              <a:t>2.  American Premium:</a:t>
-            </a:r>
-          </a:p>
-        </p:txBody>
-      </p:sp>
-      <p:sp>
-        <p:nvSpPr>
-          <p:cNvPr id="10" name="TextBox 9"/>
-          <p:cNvSpPr txBox="1"/>
-          <p:nvPr/>
-        </p:nvSpPr>
-        <p:spPr>
-          <a:xfrm>
-            <a:off x="2011680" y="3227832"/>
-            <a:ext cx="6949440" cy="475488"/>
-          </a:xfrm>
-          <a:prstGeom prst="rect">
-            <a:avLst/>
-          </a:prstGeom>
-          <a:noFill/>
-        </p:spPr>
-        <p:txBody>
-          <a:bodyPr wrap="square"/>
-          <a:lstStyle/>
-          <a:p>
-            <a:pPr algn="l"/>
-            <a:r>
-              <a:rPr sz="900" b="0" i="0">
-                <a:solidFill>
-                  <a:srgbClr val="2D3A6B"/>
-                </a:solidFill>
-                <a:latin typeface="Calibri"/>
-              </a:rPr>
-              <a:t>Small (&lt;1.2%) at 6-month maturity — European pricing retained. American pricer available for longer maturities.</a:t>
-            </a:r>
-          </a:p>
-        </p:txBody>
-      </p:sp>
-      <p:sp>
-        <p:nvSpPr>
-          <p:cNvPr id="11" name="TextBox 10"/>
-          <p:cNvSpPr txBox="1"/>
-          <p:nvPr/>
-        </p:nvSpPr>
-        <p:spPr>
-          <a:xfrm>
-            <a:off x="182880" y="3758184"/>
-            <a:ext cx="1828800" cy="475488"/>
-          </a:xfrm>
-          <a:prstGeom prst="rect">
-            <a:avLst/>
-          </a:prstGeom>
-          <a:noFill/>
-        </p:spPr>
-        <p:txBody>
-          <a:bodyPr wrap="none">
-            <a:spAutoFit/>
-          </a:bodyPr>
-          <a:lstStyle/>
-          <a:p>
-            <a:r>
-              <a:rPr sz="900" b="1">
-                <a:solidFill>
-                  <a:srgbClr val="5B8DEF"/>
-                </a:solidFill>
-                <a:latin typeface="Calibri"/>
-              </a:rPr>
-              <a:t>3.  MC Validation:</a:t>
-            </a:r>
-          </a:p>
-        </p:txBody>
-      </p:sp>
-      <p:sp>
-        <p:nvSpPr>
-          <p:cNvPr id="12" name="TextBox 11"/>
-          <p:cNvSpPr txBox="1"/>
-          <p:nvPr/>
-        </p:nvSpPr>
-        <p:spPr>
-          <a:xfrm>
-            <a:off x="2011680" y="3758184"/>
-            <a:ext cx="6949440" cy="475488"/>
-          </a:xfrm>
-          <a:prstGeom prst="rect">
-            <a:avLst/>
-          </a:prstGeom>
-          <a:noFill/>
-        </p:spPr>
-        <p:txBody>
-          <a:bodyPr wrap="square"/>
-          <a:lstStyle/>
-          <a:p>
-            <a:pPr algn="l"/>
-            <a:r>
-              <a:rPr sz="900" b="0" i="0">
-                <a:solidFill>
-                  <a:srgbClr val="2D3A6B"/>
-                </a:solidFill>
-                <a:latin typeface="Calibri"/>
-              </a:rPr>
-              <a:t>All four positions agree with BS to within $0.01 at 100k paths with antithetic variates.</a:t>
-            </a:r>
-          </a:p>
-        </p:txBody>
-      </p:sp>
+        </p:spPr>
+      </p:pic>
     </p:spTree>
   </p:cSld>
   <p:clrMapOvr>
@@ -17299,8 +15706,8 @@
           <p:nvPr/>
         </p:nvGraphicFramePr>
         <p:xfrm>
-          <a:off x="457200" y="1005840"/>
-          <a:ext cx="8229600" cy="1463040"/>
+          <a:off x="182880" y="1005840"/>
+          <a:ext cx="3657600" cy="1325880"/>
         </p:xfrm>
         <a:graphic>
           <a:graphicData uri="http://schemas.openxmlformats.org/drawingml/2006/table">
@@ -17309,20 +15716,20 @@
                 <a:tableStyleId>{5C22544A-7EE6-4342-B048-85BDC9FD1C3A}</a:tableStyleId>
               </a:tblPr>
               <a:tblGrid>
+                <a:gridCol w="548640"/>
+                <a:gridCol w="1645920"/>
                 <a:gridCol w="914400"/>
-                <a:gridCol w="3200400"/>
-                <a:gridCol w="2286000"/>
-                <a:gridCol w="1828800"/>
+                <a:gridCol w="548640"/>
               </a:tblGrid>
-              <a:tr h="292608">
-                <a:tc>
-                  <a:txBody>
-                    <a:bodyPr wrap="square"/>
-                    <a:lstStyle/>
-                    <a:p>
-                      <a:pPr algn="ctr"/>
-                      <a:r>
-                        <a:rPr sz="1100" b="1" i="0">
+              <a:tr h="265176">
+                <a:tc>
+                  <a:txBody>
+                    <a:bodyPr wrap="square"/>
+                    <a:lstStyle/>
+                    <a:p>
+                      <a:pPr algn="ctr"/>
+                      <a:r>
+                        <a:rPr sz="900" b="1" i="0">
                           <a:solidFill>
                             <a:srgbClr val="FFFFFF"/>
                           </a:solidFill>
@@ -17345,7 +15752,7 @@
                     <a:p>
                       <a:pPr algn="ctr"/>
                       <a:r>
-                        <a:rPr sz="1100" b="1" i="0">
+                        <a:rPr sz="900" b="1" i="0">
                           <a:solidFill>
                             <a:srgbClr val="FFFFFF"/>
                           </a:solidFill>
@@ -17368,7 +15775,7 @@
                     <a:p>
                       <a:pPr algn="ctr"/>
                       <a:r>
-                        <a:rPr sz="1100" b="1" i="0">
+                        <a:rPr sz="900" b="1" i="0">
                           <a:solidFill>
                             <a:srgbClr val="FFFFFF"/>
                           </a:solidFill>
@@ -17391,7 +15798,7 @@
                     <a:p>
                       <a:pPr algn="ctr"/>
                       <a:r>
-                        <a:rPr sz="1100" b="1" i="0">
+                        <a:rPr sz="900" b="1" i="0">
                           <a:solidFill>
                             <a:srgbClr val="FFFFFF"/>
                           </a:solidFill>
@@ -17408,7 +15815,7 @@
                   </a:tcPr>
                 </a:tc>
               </a:tr>
-              <a:tr h="292608">
+              <a:tr h="265176">
                 <a:tc>
                   <a:txBody>
                     <a:bodyPr wrap="square"/>
@@ -17416,7 +15823,7 @@
                     <a:p>
                       <a:pPr algn="l"/>
                       <a:r>
-                        <a:rPr sz="1100" b="0" i="0">
+                        <a:rPr sz="900" b="0" i="0">
                           <a:solidFill>
                             <a:srgbClr val="2D3A6B"/>
                           </a:solidFill>
@@ -17439,7 +15846,7 @@
                     <a:p>
                       <a:pPr algn="l"/>
                       <a:r>
-                        <a:rPr sz="1100" b="0" i="0">
+                        <a:rPr sz="900" b="0" i="0">
                           <a:solidFill>
                             <a:srgbClr val="2D3A6B"/>
                           </a:solidFill>
@@ -17462,7 +15869,7 @@
                     <a:p>
                       <a:pPr algn="ctr"/>
                       <a:r>
-                        <a:rPr sz="1100" b="0" i="0">
+                        <a:rPr sz="900" b="0" i="0">
                           <a:solidFill>
                             <a:srgbClr val="2D3A6B"/>
                           </a:solidFill>
@@ -17485,7 +15892,7 @@
                     <a:p>
                       <a:pPr algn="ctr"/>
                       <a:r>
-                        <a:rPr sz="1100" b="0" i="0">
+                        <a:rPr sz="900" b="0" i="0">
                           <a:solidFill>
                             <a:srgbClr val="2D3A6B"/>
                           </a:solidFill>
@@ -17502,7 +15909,7 @@
                   </a:tcPr>
                 </a:tc>
               </a:tr>
-              <a:tr h="292608">
+              <a:tr h="265176">
                 <a:tc>
                   <a:txBody>
                     <a:bodyPr wrap="square"/>
@@ -17510,7 +15917,7 @@
                     <a:p>
                       <a:pPr algn="l"/>
                       <a:r>
-                        <a:rPr sz="1100" b="0" i="0">
+                        <a:rPr sz="900" b="0" i="0">
                           <a:solidFill>
                             <a:srgbClr val="2D3A6B"/>
                           </a:solidFill>
@@ -17533,7 +15940,7 @@
                     <a:p>
                       <a:pPr algn="l"/>
                       <a:r>
-                        <a:rPr sz="1100" b="0" i="0">
+                        <a:rPr sz="900" b="0" i="0">
                           <a:solidFill>
                             <a:srgbClr val="2D3A6B"/>
                           </a:solidFill>
@@ -17556,7 +15963,7 @@
                     <a:p>
                       <a:pPr algn="ctr"/>
                       <a:r>
-                        <a:rPr sz="1100" b="0" i="0">
+                        <a:rPr sz="900" b="0" i="0">
                           <a:solidFill>
                             <a:srgbClr val="2D3A6B"/>
                           </a:solidFill>
@@ -17579,7 +15986,7 @@
                     <a:p>
                       <a:pPr algn="ctr"/>
                       <a:r>
-                        <a:rPr sz="1100" b="0" i="0">
+                        <a:rPr sz="900" b="0" i="0">
                           <a:solidFill>
                             <a:srgbClr val="2D3A6B"/>
                           </a:solidFill>
@@ -17596,7 +16003,7 @@
                   </a:tcPr>
                 </a:tc>
               </a:tr>
-              <a:tr h="292608">
+              <a:tr h="265176">
                 <a:tc>
                   <a:txBody>
                     <a:bodyPr wrap="square"/>
@@ -17604,7 +16011,7 @@
                     <a:p>
                       <a:pPr algn="l"/>
                       <a:r>
-                        <a:rPr sz="1100" b="0" i="0">
+                        <a:rPr sz="900" b="0" i="0">
                           <a:solidFill>
                             <a:srgbClr val="2D3A6B"/>
                           </a:solidFill>
@@ -17627,7 +16034,7 @@
                     <a:p>
                       <a:pPr algn="l"/>
                       <a:r>
-                        <a:rPr sz="1100" b="0" i="0">
+                        <a:rPr sz="900" b="0" i="0">
                           <a:solidFill>
                             <a:srgbClr val="2D3A6B"/>
                           </a:solidFill>
@@ -17650,7 +16057,7 @@
                     <a:p>
                       <a:pPr algn="ctr"/>
                       <a:r>
-                        <a:rPr sz="1100" b="0" i="0">
+                        <a:rPr sz="900" b="0" i="0">
                           <a:solidFill>
                             <a:srgbClr val="2D3A6B"/>
                           </a:solidFill>
@@ -17673,7 +16080,7 @@
                     <a:p>
                       <a:pPr algn="ctr"/>
                       <a:r>
-                        <a:rPr sz="1100" b="0" i="0">
+                        <a:rPr sz="900" b="0" i="0">
                           <a:solidFill>
                             <a:srgbClr val="2D3A6B"/>
                           </a:solidFill>
@@ -17690,7 +16097,7 @@
                   </a:tcPr>
                 </a:tc>
               </a:tr>
-              <a:tr h="292608">
+              <a:tr h="265176">
                 <a:tc>
                   <a:txBody>
                     <a:bodyPr wrap="square"/>
@@ -17698,7 +16105,7 @@
                     <a:p>
                       <a:pPr algn="l"/>
                       <a:r>
-                        <a:rPr sz="1100" b="1" i="0">
+                        <a:rPr sz="900" b="1" i="0">
                           <a:solidFill>
                             <a:srgbClr val="FFFFFF"/>
                           </a:solidFill>
@@ -17735,7 +16142,7 @@
                     <a:p>
                       <a:pPr algn="ctr"/>
                       <a:r>
-                        <a:rPr sz="1100" b="1" i="0">
+                        <a:rPr sz="900" b="1" i="0">
                           <a:solidFill>
                             <a:srgbClr val="FFFFFF"/>
                           </a:solidFill>
@@ -17758,7 +16165,7 @@
                     <a:p>
                       <a:pPr algn="ctr"/>
                       <a:r>
-                        <a:rPr sz="1100" b="1" i="0">
+                        <a:rPr sz="900" b="1" i="0">
                           <a:solidFill>
                             <a:srgbClr val="FFFFFF"/>
                           </a:solidFill>
@@ -17779,16 +16186,40 @@
           </a:graphicData>
         </a:graphic>
       </p:graphicFrame>
-      <p:sp>
-        <p:nvSpPr>
-          <p:cNvPr id="7" name="Rectangle 6"/>
+      <p:pic>
+        <p:nvPicPr>
+          <p:cNvPr id="7" name="Picture 6" descr="chart3_dollar_delta.png"/>
+          <p:cNvPicPr>
+            <a:picLocks noChangeAspect="1"/>
+          </p:cNvPicPr>
+          <p:nvPr/>
+        </p:nvPicPr>
+        <p:blipFill>
+          <a:blip r:embed="rId2"/>
+          <a:stretch>
+            <a:fillRect/>
+          </a:stretch>
+        </p:blipFill>
+        <p:spPr>
+          <a:xfrm>
+            <a:off x="3977639" y="960120"/>
+            <a:ext cx="5029200" cy="3977639"/>
+          </a:xfrm>
+          <a:prstGeom prst="rect">
+            <a:avLst/>
+          </a:prstGeom>
+        </p:spPr>
+      </p:pic>
+      <p:sp>
+        <p:nvSpPr>
+          <p:cNvPr id="8" name="Rectangle 7"/>
           <p:cNvSpPr/>
           <p:nvPr/>
         </p:nvSpPr>
         <p:spPr>
           <a:xfrm>
-            <a:off x="182880" y="2578608"/>
-            <a:ext cx="8778240" cy="2331720"/>
+            <a:off x="182880" y="2423160"/>
+            <a:ext cx="3657600" cy="2423160"/>
           </a:xfrm>
           <a:prstGeom prst="rect">
             <a:avLst/>
@@ -17824,14 +16255,14 @@
       </p:sp>
       <p:sp>
         <p:nvSpPr>
-          <p:cNvPr id="8" name="TextBox 7"/>
+          <p:cNvPr id="9" name="TextBox 8"/>
           <p:cNvSpPr txBox="1"/>
           <p:nvPr/>
         </p:nvSpPr>
         <p:spPr>
           <a:xfrm>
-            <a:off x="274320" y="2624328"/>
-            <a:ext cx="8595360" cy="274320"/>
+            <a:off x="274320" y="2468880"/>
+            <a:ext cx="3474720" cy="256032"/>
           </a:xfrm>
           <a:prstGeom prst="rect">
             <a:avLst/>
@@ -17844,7 +16275,7 @@
           <a:p>
             <a:pPr algn="l"/>
             <a:r>
-              <a:rPr sz="1100" b="1" i="0">
+              <a:rPr sz="1000" b="1" i="0">
                 <a:solidFill>
                   <a:srgbClr val="2D3A6B"/>
                 </a:solidFill>
@@ -17857,14 +16288,14 @@
       </p:sp>
       <p:sp>
         <p:nvSpPr>
-          <p:cNvPr id="9" name="TextBox 8"/>
+          <p:cNvPr id="10" name="TextBox 9"/>
           <p:cNvSpPr txBox="1"/>
           <p:nvPr/>
         </p:nvSpPr>
         <p:spPr>
           <a:xfrm>
-            <a:off x="274320" y="2926080"/>
-            <a:ext cx="8503920" cy="1920240"/>
+            <a:off x="274320" y="2752344"/>
+            <a:ext cx="3474720" cy="2011680"/>
           </a:xfrm>
           <a:prstGeom prst="rect">
             <a:avLst/>
@@ -17877,18 +16308,18 @@
           <a:p>
             <a:pPr algn="l"/>
             <a:r>
-              <a:rPr sz="1000" b="0" i="0">
+              <a:rPr sz="900" b="0" i="0">
                 <a:solidFill>
                   <a:srgbClr val="2D3A6B"/>
                 </a:solidFill>
                 <a:latin typeface="Calibri"/>
               </a:rPr>
-              <a:t>•  Portfolio total equity deployed: $299,564
-•  Net option premium: −$6,961 (net cost of overlays)
-•  Annualised portfolio vol: 18.22% (dollar-delta weighted)
-•  CBA: Put reduces directional exposure ($99k equity → $66k net delta)
-•  BHP: Short call caps upside, reduces effective exposure
-•  CSL: Straddle is delta-neutral — a pure volatility view</a:t>
+              <a:t>• Total equity: $299,564
+• Net option premium: −$6,961
+• Portfolio vol: 18.22% (annualised)
+• CBA put reduces $99k → $66k delta
+• BHP short call caps upside
+• CSL straddle = pure vol view</a:t>
             </a:r>
           </a:p>
         </p:txBody>
@@ -18065,17 +16496,41 @@
           </a:p>
         </p:txBody>
       </p:sp>
+      <p:pic>
+        <p:nvPicPr>
+          <p:cNvPr id="6" name="Picture 5" descr="chart4_pnl_distribution.png"/>
+          <p:cNvPicPr>
+            <a:picLocks noChangeAspect="1"/>
+          </p:cNvPicPr>
+          <p:nvPr/>
+        </p:nvPicPr>
+        <p:blipFill>
+          <a:blip r:embed="rId2"/>
+          <a:stretch>
+            <a:fillRect/>
+          </a:stretch>
+        </p:blipFill>
+        <p:spPr>
+          <a:xfrm>
+            <a:off x="137160" y="987552"/>
+            <a:ext cx="5760720" cy="3977639"/>
+          </a:xfrm>
+          <a:prstGeom prst="rect">
+            <a:avLst/>
+          </a:prstGeom>
+        </p:spPr>
+      </p:pic>
       <p:graphicFrame>
         <p:nvGraphicFramePr>
-          <p:cNvPr id="6" name="Table 5"/>
+          <p:cNvPr id="7" name="Table 6"/>
           <p:cNvGraphicFramePr>
             <a:graphicFrameLocks noGrp="1"/>
           </p:cNvGraphicFramePr>
           <p:nvPr/>
         </p:nvGraphicFramePr>
         <p:xfrm>
-          <a:off x="228600" y="1005840"/>
-          <a:ext cx="8686800" cy="1920240"/>
+          <a:off x="5989320" y="1005840"/>
+          <a:ext cx="3017520" cy="1920240"/>
         </p:xfrm>
         <a:graphic>
           <a:graphicData uri="http://schemas.openxmlformats.org/drawingml/2006/table">
@@ -18084,9 +16539,8 @@
                 <a:tableStyleId>{5C22544A-7EE6-4342-B048-85BDC9FD1C3A}</a:tableStyleId>
               </a:tblPr>
               <a:tblGrid>
-                <a:gridCol w="3200400"/>
-                <a:gridCol w="1645920"/>
-                <a:gridCol w="3840480"/>
+                <a:gridCol w="1783080"/>
+                <a:gridCol w="1234440"/>
               </a:tblGrid>
               <a:tr h="320040">
                 <a:tc>
@@ -18096,7 +16550,7 @@
                     <a:p>
                       <a:pPr algn="ctr"/>
                       <a:r>
-                        <a:rPr sz="1100" b="1" i="0">
+                        <a:rPr sz="900" b="1" i="0">
                           <a:solidFill>
                             <a:srgbClr val="FFFFFF"/>
                           </a:solidFill>
@@ -18119,36 +16573,13 @@
                     <a:p>
                       <a:pPr algn="ctr"/>
                       <a:r>
-                        <a:rPr sz="1100" b="1" i="0">
+                        <a:rPr sz="900" b="1" i="0">
                           <a:solidFill>
                             <a:srgbClr val="FFFFFF"/>
                           </a:solidFill>
                           <a:latin typeface="Calibri"/>
                         </a:rPr>
                         <a:t>95% VaR ($)</a:t>
-                      </a:r>
-                    </a:p>
-                  </a:txBody>
-                  <a:tcPr>
-                    <a:solidFill>
-                      <a:srgbClr val="2D3A6B"/>
-                    </a:solidFill>
-                  </a:tcPr>
-                </a:tc>
-                <a:tc>
-                  <a:txBody>
-                    <a:bodyPr wrap="square"/>
-                    <a:lstStyle/>
-                    <a:p>
-                      <a:pPr algn="ctr"/>
-                      <a:r>
-                        <a:rPr sz="1100" b="1" i="0">
-                          <a:solidFill>
-                            <a:srgbClr val="FFFFFF"/>
-                          </a:solidFill>
-                          <a:latin typeface="Calibri"/>
-                        </a:rPr>
-                        <a:t>Notes</a:t>
                       </a:r>
                     </a:p>
                   </a:txBody>
@@ -18167,7 +16598,7 @@
                     <a:p>
                       <a:pPr algn="l"/>
                       <a:r>
-                        <a:rPr sz="1000" b="0" i="0">
+                        <a:rPr sz="900" b="0" i="0">
                           <a:solidFill>
                             <a:srgbClr val="2D3A6B"/>
                           </a:solidFill>
@@ -18190,36 +16621,13 @@
                     <a:p>
                       <a:pPr algn="ctr"/>
                       <a:r>
-                        <a:rPr sz="1000" b="0" i="0">
+                        <a:rPr sz="900" b="0" i="0">
                           <a:solidFill>
                             <a:srgbClr val="2D3A6B"/>
                           </a:solidFill>
                           <a:latin typeface="Calibri"/>
                         </a:rPr>
                         <a:t>11,825</a:t>
-                      </a:r>
-                    </a:p>
-                  </a:txBody>
-                  <a:tcPr>
-                    <a:solidFill>
-                      <a:srgbClr val="F0F4FF"/>
-                    </a:solidFill>
-                  </a:tcPr>
-                </a:tc>
-                <a:tc>
-                  <a:txBody>
-                    <a:bodyPr wrap="square"/>
-                    <a:lstStyle/>
-                    <a:p>
-                      <a:pPr algn="l"/>
-                      <a:r>
-                        <a:rPr sz="1000" b="0" i="0">
-                          <a:solidFill>
-                            <a:srgbClr val="2D3A6B"/>
-                          </a:solidFill>
-                          <a:latin typeface="Calibri"/>
-                        </a:rPr>
-                        <a:t>Empirical quantile; captures fat tails</a:t>
                       </a:r>
                     </a:p>
                   </a:txBody>
@@ -18238,7 +16646,7 @@
                     <a:p>
                       <a:pPr algn="l"/>
                       <a:r>
-                        <a:rPr sz="1000" b="0" i="0">
+                        <a:rPr sz="900" b="0" i="0">
                           <a:solidFill>
                             <a:srgbClr val="2D3A6B"/>
                           </a:solidFill>
@@ -18261,36 +16669,13 @@
                     <a:p>
                       <a:pPr algn="ctr"/>
                       <a:r>
-                        <a:rPr sz="1000" b="0" i="0">
+                        <a:rPr sz="900" b="0" i="0">
                           <a:solidFill>
                             <a:srgbClr val="2D3A6B"/>
                           </a:solidFill>
                           <a:latin typeface="Calibri"/>
                         </a:rPr>
                         <a:t>13,583</a:t>
-                      </a:r>
-                    </a:p>
-                  </a:txBody>
-                  <a:tcPr>
-                    <a:solidFill>
-                      <a:srgbClr val="FFFFFF"/>
-                    </a:solidFill>
-                  </a:tcPr>
-                </a:tc>
-                <a:tc>
-                  <a:txBody>
-                    <a:bodyPr wrap="square"/>
-                    <a:lstStyle/>
-                    <a:p>
-                      <a:pPr algn="l"/>
-                      <a:r>
-                        <a:rPr sz="1000" b="0" i="0">
-                          <a:solidFill>
-                            <a:srgbClr val="2D3A6B"/>
-                          </a:solidFill>
-                          <a:latin typeface="Calibri"/>
-                        </a:rPr>
-                        <a:t>Gaussian (z₅₅ × σ); assumes normality</a:t>
                       </a:r>
                     </a:p>
                   </a:txBody>
@@ -18309,13 +16694,13 @@
                     <a:p>
                       <a:pPr algn="l"/>
                       <a:r>
-                        <a:rPr sz="1000" b="0" i="0">
-                          <a:solidFill>
-                            <a:srgbClr val="2D3A6B"/>
-                          </a:solidFill>
-                          <a:latin typeface="Calibri"/>
-                        </a:rPr>
-                        <a:t>Multi-asset correlated MC</a:t>
+                        <a:rPr sz="900" b="0" i="0">
+                          <a:solidFill>
+                            <a:srgbClr val="2D3A6B"/>
+                          </a:solidFill>
+                          <a:latin typeface="Calibri"/>
+                        </a:rPr>
+                        <a:t>MC correlated</a:t>
                       </a:r>
                     </a:p>
                   </a:txBody>
@@ -18332,36 +16717,13 @@
                     <a:p>
                       <a:pPr algn="ctr"/>
                       <a:r>
-                        <a:rPr sz="1000" b="0" i="0">
+                        <a:rPr sz="900" b="0" i="0">
                           <a:solidFill>
                             <a:srgbClr val="2D3A6B"/>
                           </a:solidFill>
                           <a:latin typeface="Calibri"/>
                         </a:rPr>
                         <a:t>12,775</a:t>
-                      </a:r>
-                    </a:p>
-                  </a:txBody>
-                  <a:tcPr>
-                    <a:solidFill>
-                      <a:srgbClr val="F0F4FF"/>
-                    </a:solidFill>
-                  </a:tcPr>
-                </a:tc>
-                <a:tc>
-                  <a:txBody>
-                    <a:bodyPr wrap="square"/>
-                    <a:lstStyle/>
-                    <a:p>
-                      <a:pPr algn="l"/>
-                      <a:r>
-                        <a:rPr sz="1000" b="0" i="0">
-                          <a:solidFill>
-                            <a:srgbClr val="2D3A6B"/>
-                          </a:solidFill>
-                          <a:latin typeface="Calibri"/>
-                        </a:rPr>
-                        <a:t>Full revaluation, 5,000 paths, empirical ρ</a:t>
                       </a:r>
                     </a:p>
                   </a:txBody>
@@ -18380,13 +16742,13 @@
                     <a:p>
                       <a:pPr algn="l"/>
                       <a:r>
-                        <a:rPr sz="1000" b="0" i="0">
-                          <a:solidFill>
-                            <a:srgbClr val="2D3A6B"/>
-                          </a:solidFill>
-                          <a:latin typeface="Calibri"/>
-                        </a:rPr>
-                        <a:t>Expected Shortfall (Hist)</a:t>
+                        <a:rPr sz="900" b="0" i="0">
+                          <a:solidFill>
+                            <a:srgbClr val="2D3A6B"/>
+                          </a:solidFill>
+                          <a:latin typeface="Calibri"/>
+                        </a:rPr>
+                        <a:t>ES (Hist)</a:t>
                       </a:r>
                     </a:p>
                   </a:txBody>
@@ -18403,36 +16765,13 @@
                     <a:p>
                       <a:pPr algn="ctr"/>
                       <a:r>
-                        <a:rPr sz="1000" b="0" i="0">
+                        <a:rPr sz="900" b="0" i="0">
                           <a:solidFill>
                             <a:srgbClr val="2D3A6B"/>
                           </a:solidFill>
                           <a:latin typeface="Calibri"/>
                         </a:rPr>
                         <a:t>21,431</a:t>
-                      </a:r>
-                    </a:p>
-                  </a:txBody>
-                  <a:tcPr>
-                    <a:solidFill>
-                      <a:srgbClr val="FFFFFF"/>
-                    </a:solidFill>
-                  </a:tcPr>
-                </a:tc>
-                <a:tc>
-                  <a:txBody>
-                    <a:bodyPr wrap="square"/>
-                    <a:lstStyle/>
-                    <a:p>
-                      <a:pPr algn="l"/>
-                      <a:r>
-                        <a:rPr sz="1000" b="0" i="0">
-                          <a:solidFill>
-                            <a:srgbClr val="2D3A6B"/>
-                          </a:solidFill>
-                          <a:latin typeface="Calibri"/>
-                        </a:rPr>
-                        <a:t>Mean loss in worst 5% tail</a:t>
                       </a:r>
                     </a:p>
                   </a:txBody>
@@ -18451,13 +16790,13 @@
                     <a:p>
                       <a:pPr algn="l"/>
                       <a:r>
-                        <a:rPr sz="1000" b="0" i="0">
-                          <a:solidFill>
-                            <a:srgbClr val="2D3A6B"/>
-                          </a:solidFill>
-                          <a:latin typeface="Calibri"/>
-                        </a:rPr>
-                        <a:t>Expected Shortfall (MC)</a:t>
+                        <a:rPr sz="900" b="0" i="0">
+                          <a:solidFill>
+                            <a:srgbClr val="2D3A6B"/>
+                          </a:solidFill>
+                          <a:latin typeface="Calibri"/>
+                        </a:rPr>
+                        <a:t>ES (MC)</a:t>
                       </a:r>
                     </a:p>
                   </a:txBody>
@@ -18474,36 +16813,13 @@
                     <a:p>
                       <a:pPr algn="ctr"/>
                       <a:r>
-                        <a:rPr sz="1000" b="0" i="0">
+                        <a:rPr sz="900" b="0" i="0">
                           <a:solidFill>
                             <a:srgbClr val="2D3A6B"/>
                           </a:solidFill>
                           <a:latin typeface="Calibri"/>
                         </a:rPr>
                         <a:t>15,599</a:t>
-                      </a:r>
-                    </a:p>
-                  </a:txBody>
-                  <a:tcPr>
-                    <a:solidFill>
-                      <a:srgbClr val="F0F4FF"/>
-                    </a:solidFill>
-                  </a:tcPr>
-                </a:tc>
-                <a:tc>
-                  <a:txBody>
-                    <a:bodyPr wrap="square"/>
-                    <a:lstStyle/>
-                    <a:p>
-                      <a:pPr algn="l"/>
-                      <a:r>
-                        <a:rPr sz="1000" b="0" i="0">
-                          <a:solidFill>
-                            <a:srgbClr val="2D3A6B"/>
-                          </a:solidFill>
-                          <a:latin typeface="Calibri"/>
-                        </a:rPr>
-                        <a:t>Mean loss in worst 5% tail (MC)</a:t>
                       </a:r>
                     </a:p>
                   </a:txBody>
@@ -18520,20 +16836,20 @@
       </p:graphicFrame>
       <p:sp>
         <p:nvSpPr>
-          <p:cNvPr id="7" name="Rectangle 6"/>
+          <p:cNvPr id="8" name="Rectangle 7"/>
           <p:cNvSpPr/>
           <p:nvPr/>
         </p:nvSpPr>
         <p:spPr>
           <a:xfrm>
-            <a:off x="228600" y="3017520"/>
-            <a:ext cx="8686800" cy="457200"/>
+            <a:off x="5989320" y="3017520"/>
+            <a:ext cx="3017520" cy="1920240"/>
           </a:xfrm>
           <a:prstGeom prst="rect">
             <a:avLst/>
           </a:prstGeom>
           <a:solidFill>
-            <a:srgbClr val="D0DBFF"/>
+            <a:srgbClr val="2D3A6B"/>
           </a:solidFill>
           <a:ln>
             <a:noFill/>
@@ -18563,14 +16879,14 @@
       </p:sp>
       <p:sp>
         <p:nvSpPr>
-          <p:cNvPr id="8" name="TextBox 7"/>
+          <p:cNvPr id="9" name="TextBox 8"/>
           <p:cNvSpPr txBox="1"/>
           <p:nvPr/>
         </p:nvSpPr>
         <p:spPr>
           <a:xfrm>
-            <a:off x="320040" y="3063240"/>
-            <a:ext cx="8412480" cy="256032"/>
+            <a:off x="6080760" y="3072384"/>
+            <a:ext cx="2834640" cy="256032"/>
           </a:xfrm>
           <a:prstGeom prst="rect">
             <a:avLst/>
@@ -18583,116 +16899,7 @@
           <a:p>
             <a:pPr algn="l"/>
             <a:r>
-              <a:rPr sz="1000" b="1" i="0">
-                <a:solidFill>
-                  <a:srgbClr val="2D3A6B"/>
-                </a:solidFill>
-                <a:latin typeface="Calibri"/>
-              </a:rPr>
-              <a:t>Return Distribution Stats</a:t>
-            </a:r>
-          </a:p>
-        </p:txBody>
-      </p:sp>
-      <p:sp>
-        <p:nvSpPr>
-          <p:cNvPr id="9" name="TextBox 8"/>
-          <p:cNvSpPr txBox="1"/>
-          <p:nvPr/>
-        </p:nvSpPr>
-        <p:spPr>
-          <a:xfrm>
-            <a:off x="320040" y="3273552"/>
-            <a:ext cx="8412480" cy="164592"/>
-          </a:xfrm>
-          <a:prstGeom prst="rect">
-            <a:avLst/>
-          </a:prstGeom>
-          <a:noFill/>
-        </p:spPr>
-        <p:txBody>
-          <a:bodyPr wrap="square"/>
-          <a:lstStyle/>
-          <a:p>
-            <a:pPr algn="l"/>
-            <a:r>
-              <a:rPr sz="900" b="0" i="0">
-                <a:solidFill>
-                  <a:srgbClr val="2D3A6B"/>
-                </a:solidFill>
-                <a:latin typeface="Calibri"/>
-              </a:rPr>
-              <a:t>Annualised Vol: 18.22%   │   Skewness: Negative   │   Excess Kurtosis: Positive (leptokurtic)</a:t>
-            </a:r>
-          </a:p>
-        </p:txBody>
-      </p:sp>
-      <p:sp>
-        <p:nvSpPr>
-          <p:cNvPr id="10" name="Rectangle 9"/>
-          <p:cNvSpPr/>
-          <p:nvPr/>
-        </p:nvSpPr>
-        <p:spPr>
-          <a:xfrm>
-            <a:off x="228600" y="3538728"/>
-            <a:ext cx="8686800" cy="804672"/>
-          </a:xfrm>
-          <a:prstGeom prst="rect">
-            <a:avLst/>
-          </a:prstGeom>
-          <a:solidFill>
-            <a:srgbClr val="2D3A6B"/>
-          </a:solidFill>
-          <a:ln>
-            <a:noFill/>
-          </a:ln>
-        </p:spPr>
-        <p:style>
-          <a:lnRef idx="1">
-            <a:schemeClr val="accent1"/>
-          </a:lnRef>
-          <a:fillRef idx="3">
-            <a:schemeClr val="accent1"/>
-          </a:fillRef>
-          <a:effectRef idx="2">
-            <a:schemeClr val="accent1"/>
-          </a:effectRef>
-          <a:fontRef idx="minor">
-            <a:schemeClr val="lt1"/>
-          </a:fontRef>
-        </p:style>
-        <p:txBody>
-          <a:bodyPr rtlCol="0" anchor="ctr"/>
-          <a:lstStyle/>
-          <a:p>
-            <a:pPr algn="ctr"/>
-          </a:p>
-        </p:txBody>
-      </p:sp>
-      <p:sp>
-        <p:nvSpPr>
-          <p:cNvPr id="11" name="TextBox 10"/>
-          <p:cNvSpPr txBox="1"/>
-          <p:nvPr/>
-        </p:nvSpPr>
-        <p:spPr>
-          <a:xfrm>
-            <a:off x="320040" y="3593592"/>
-            <a:ext cx="8412480" cy="256032"/>
-          </a:xfrm>
-          <a:prstGeom prst="rect">
-            <a:avLst/>
-          </a:prstGeom>
-          <a:noFill/>
-        </p:spPr>
-        <p:txBody>
-          <a:bodyPr wrap="square"/>
-          <a:lstStyle/>
-          <a:p>
-            <a:pPr algn="l"/>
-            <a:r>
-              <a:rPr sz="1000" b="1" i="0">
+              <a:rPr sz="900" b="1" i="0">
                 <a:solidFill>
                   <a:srgbClr val="5B8DEF"/>
                 </a:solidFill>
@@ -18705,14 +16912,14 @@
       </p:sp>
       <p:sp>
         <p:nvSpPr>
-          <p:cNvPr id="12" name="TextBox 11"/>
+          <p:cNvPr id="10" name="TextBox 9"/>
           <p:cNvSpPr txBox="1"/>
           <p:nvPr/>
         </p:nvSpPr>
         <p:spPr>
           <a:xfrm>
-            <a:off x="320040" y="3831336"/>
-            <a:ext cx="8412480" cy="457200"/>
+            <a:off x="6080760" y="3328416"/>
+            <a:ext cx="2834640" cy="1508760"/>
           </a:xfrm>
           <a:prstGeom prst="rect">
             <a:avLst/>
@@ -18725,13 +16932,16 @@
           <a:p>
             <a:pPr algn="l"/>
             <a:r>
-              <a:rPr sz="900" b="0" i="0">
+              <a:rPr sz="850" b="0" i="0">
                 <a:solidFill>
                   <a:srgbClr val="FFFFFF"/>
                 </a:solidFill>
                 <a:latin typeface="Calibri"/>
               </a:rPr>
-              <a:t>Historical VaR &lt; Parametric VaR — real returns are leptokurtic (fat tails). The empirical 5th percentile is more extreme than −1.645σ implies under normality.</a:t>
+              <a:t>Hist VaR &lt; Param VaR — real returns are leptokurtic (fat tails). Empirical 5th pctl is more extreme than −1.645σ implies.
+Ann. Vol: 18.22%
+Skewness: Negative
+Kurtosis: Leptokurtic</a:t>
             </a:r>
           </a:p>
         </p:txBody>

</xml_diff>